<commit_message>
App User Web Python Paradigmas 14102025
</commit_message>
<xml_diff>
--- a/01 Classes/Aula 12, 13 Programação Python - Banco de Dados.pptx
+++ b/01 Classes/Aula 12, 13 Programação Python - Banco de Dados.pptx
@@ -1313,7 +1313,7 @@
           <a:p>
             <a:fld id="{48A87A34-81AB-432B-8DAE-1953F412C126}" type="datetimeFigureOut">
               <a:rPr lang="en-US" smtClean="0"/>
-              <a:t>10/16/2023</a:t>
+              <a:t>10/14/2025</a:t>
             </a:fld>
             <a:endParaRPr lang="en-US" dirty="0"/>
           </a:p>
@@ -1524,7 +1524,7 @@
           <a:p>
             <a:fld id="{48A87A34-81AB-432B-8DAE-1953F412C126}" type="datetimeFigureOut">
               <a:rPr lang="en-US" smtClean="0"/>
-              <a:t>10/16/2023</a:t>
+              <a:t>10/14/2025</a:t>
             </a:fld>
             <a:endParaRPr lang="en-US" dirty="0"/>
           </a:p>
@@ -1739,7 +1739,7 @@
           <a:p>
             <a:fld id="{48A87A34-81AB-432B-8DAE-1953F412C126}" type="datetimeFigureOut">
               <a:rPr lang="en-US" smtClean="0"/>
-              <a:t>10/16/2023</a:t>
+              <a:t>10/14/2025</a:t>
             </a:fld>
             <a:endParaRPr lang="en-US" dirty="0"/>
           </a:p>
@@ -2107,7 +2107,7 @@
           <a:p>
             <a:fld id="{48A87A34-81AB-432B-8DAE-1953F412C126}" type="datetimeFigureOut">
               <a:rPr lang="en-US" smtClean="0"/>
-              <a:t>10/16/2023</a:t>
+              <a:t>10/14/2025</a:t>
             </a:fld>
             <a:endParaRPr lang="en-US" dirty="0"/>
           </a:p>
@@ -2386,7 +2386,7 @@
           <a:p>
             <a:fld id="{48A87A34-81AB-432B-8DAE-1953F412C126}" type="datetimeFigureOut">
               <a:rPr lang="en-US" smtClean="0"/>
-              <a:t>10/16/2023</a:t>
+              <a:t>10/14/2025</a:t>
             </a:fld>
             <a:endParaRPr lang="en-US" dirty="0"/>
           </a:p>
@@ -2654,7 +2654,7 @@
           <a:p>
             <a:fld id="{48A87A34-81AB-432B-8DAE-1953F412C126}" type="datetimeFigureOut">
               <a:rPr lang="en-US" smtClean="0"/>
-              <a:t>10/16/2023</a:t>
+              <a:t>10/14/2025</a:t>
             </a:fld>
             <a:endParaRPr lang="en-US" dirty="0"/>
           </a:p>
@@ -3070,7 +3070,7 @@
           <a:p>
             <a:fld id="{48A87A34-81AB-432B-8DAE-1953F412C126}" type="datetimeFigureOut">
               <a:rPr lang="en-US" smtClean="0"/>
-              <a:t>10/16/2023</a:t>
+              <a:t>10/14/2025</a:t>
             </a:fld>
             <a:endParaRPr lang="en-US" dirty="0"/>
           </a:p>
@@ -3219,7 +3219,7 @@
           <a:p>
             <a:fld id="{48A87A34-81AB-432B-8DAE-1953F412C126}" type="datetimeFigureOut">
               <a:rPr lang="en-US" smtClean="0"/>
-              <a:t>10/16/2023</a:t>
+              <a:t>10/14/2025</a:t>
             </a:fld>
             <a:endParaRPr lang="en-US" dirty="0"/>
           </a:p>
@@ -3345,7 +3345,7 @@
           <a:p>
             <a:fld id="{48A87A34-81AB-432B-8DAE-1953F412C126}" type="datetimeFigureOut">
               <a:rPr lang="en-US" smtClean="0"/>
-              <a:t>10/16/2023</a:t>
+              <a:t>10/14/2025</a:t>
             </a:fld>
             <a:endParaRPr lang="en-US" dirty="0"/>
           </a:p>
@@ -3596,7 +3596,7 @@
           <a:p>
             <a:fld id="{48A87A34-81AB-432B-8DAE-1953F412C126}" type="datetimeFigureOut">
               <a:rPr lang="en-US" smtClean="0"/>
-              <a:t>10/16/2023</a:t>
+              <a:t>10/14/2025</a:t>
             </a:fld>
             <a:endParaRPr lang="en-US" dirty="0"/>
           </a:p>
@@ -4042,7 +4042,7 @@
             <a:fld id="{48A87A34-81AB-432B-8DAE-1953F412C126}" type="datetimeFigureOut">
               <a:rPr lang="en-US" smtClean="0"/>
               <a:pPr/>
-              <a:t>10/16/2023</a:t>
+              <a:t>10/14/2025</a:t>
             </a:fld>
             <a:endParaRPr lang="en-US" dirty="0"/>
           </a:p>
@@ -4209,6 +4209,13 @@
             <a:schemeClr val="lt1"/>
           </a:fontRef>
         </p:style>
+        <p:txBody>
+          <a:bodyPr/>
+          <a:lstStyle/>
+          <a:p>
+            <a:endParaRPr lang="pt-BR"/>
+          </a:p>
+        </p:txBody>
       </p:sp>
       <p:pic>
         <p:nvPicPr>
@@ -4370,7 +4377,7 @@
             <a:fld id="{48A87A34-81AB-432B-8DAE-1953F412C126}" type="datetimeFigureOut">
               <a:rPr lang="en-US" smtClean="0"/>
               <a:pPr/>
-              <a:t>10/16/2023</a:t>
+              <a:t>10/14/2025</a:t>
             </a:fld>
             <a:endParaRPr lang="en-US" dirty="0"/>
           </a:p>
@@ -5472,7 +5479,7 @@
               <a:buNone/>
             </a:pPr>
             <a:r>
-              <a:rPr lang="pt-BR" sz="2400" dirty="0">
+              <a:rPr lang="pt-BR" sz="2000" dirty="0">
                 <a:solidFill>
                   <a:schemeClr val="tx1"/>
                 </a:solidFill>
@@ -5482,7 +5489,7 @@
               <a:t>cursor = </a:t>
             </a:r>
             <a:r>
-              <a:rPr lang="pt-BR" sz="2400" dirty="0" err="1">
+              <a:rPr lang="pt-BR" sz="2000" dirty="0" err="1">
                 <a:solidFill>
                   <a:schemeClr val="tx1"/>
                 </a:solidFill>
@@ -5492,7 +5499,7 @@
               <a:t>conn.</a:t>
             </a:r>
             <a:r>
-              <a:rPr lang="pt-BR" sz="2400" b="1" dirty="0" err="1">
+              <a:rPr lang="pt-BR" sz="2000" b="1" dirty="0" err="1">
                 <a:solidFill>
                   <a:srgbClr val="FF0000"/>
                 </a:solidFill>
@@ -5502,7 +5509,7 @@
               <a:t>cursor</a:t>
             </a:r>
             <a:r>
-              <a:rPr lang="pt-BR" sz="2400" dirty="0">
+              <a:rPr lang="pt-BR" sz="2000" dirty="0">
                 <a:solidFill>
                   <a:schemeClr val="tx1"/>
                 </a:solidFill>
@@ -5517,13 +5524,13 @@
               <a:buNone/>
             </a:pPr>
             <a:r>
-              <a:rPr lang="pt-BR" sz="2400" dirty="0">
+              <a:rPr lang="pt-BR" sz="2000" dirty="0">
                 <a:latin typeface="Times New Roman" panose="02020603050405020304" pitchFamily="18" charset="0"/>
                 <a:cs typeface="Times New Roman" panose="02020603050405020304" pitchFamily="18" charset="0"/>
               </a:rPr>
               <a:t>id = 63</a:t>
             </a:r>
-            <a:endParaRPr lang="pt-BR" sz="2400" dirty="0">
+            <a:endParaRPr lang="pt-BR" sz="2000" dirty="0">
               <a:solidFill>
                 <a:schemeClr val="tx1"/>
               </a:solidFill>
@@ -5536,7 +5543,7 @@
               <a:buNone/>
             </a:pPr>
             <a:r>
-              <a:rPr lang="pt-BR" sz="2400" dirty="0">
+              <a:rPr lang="pt-BR" sz="2000" dirty="0">
                 <a:latin typeface="Times New Roman" panose="02020603050405020304" pitchFamily="18" charset="0"/>
                 <a:cs typeface="Times New Roman" panose="02020603050405020304" pitchFamily="18" charset="0"/>
               </a:rPr>
@@ -5548,207 +5555,193 @@
               <a:buNone/>
             </a:pPr>
             <a:r>
-              <a:rPr lang="pt-BR" sz="2400" dirty="0" err="1">
+              <a:rPr lang="pt-BR" sz="2000" dirty="0" err="1">
                 <a:latin typeface="Times New Roman" panose="02020603050405020304" pitchFamily="18" charset="0"/>
                 <a:cs typeface="Times New Roman" panose="02020603050405020304" pitchFamily="18" charset="0"/>
               </a:rPr>
               <a:t>sql</a:t>
             </a:r>
             <a:r>
-              <a:rPr lang="pt-BR" sz="2400" dirty="0">
-                <a:latin typeface="Times New Roman" panose="02020603050405020304" pitchFamily="18" charset="0"/>
-                <a:cs typeface="Times New Roman" panose="02020603050405020304" pitchFamily="18" charset="0"/>
-              </a:rPr>
-              <a:t> = </a:t>
-            </a:r>
-            <a:r>
-              <a:rPr lang="pt-BR" sz="2400" b="1" dirty="0" err="1">
+              <a:rPr lang="pt-BR" sz="2000" dirty="0">
+                <a:latin typeface="Times New Roman" panose="02020603050405020304" pitchFamily="18" charset="0"/>
+                <a:cs typeface="Times New Roman" panose="02020603050405020304" pitchFamily="18" charset="0"/>
+              </a:rPr>
+              <a:t> = "</a:t>
+            </a:r>
+            <a:r>
+              <a:rPr lang="pt-BR" sz="2000" b="1" dirty="0">
+                <a:latin typeface="Times New Roman" panose="02020603050405020304" pitchFamily="18" charset="0"/>
+                <a:cs typeface="Times New Roman" panose="02020603050405020304" pitchFamily="18" charset="0"/>
+              </a:rPr>
+              <a:t>update</a:t>
+            </a:r>
+            <a:r>
+              <a:rPr lang="pt-BR" sz="2000" dirty="0">
+                <a:latin typeface="Times New Roman" panose="02020603050405020304" pitchFamily="18" charset="0"/>
+                <a:cs typeface="Times New Roman" panose="02020603050405020304" pitchFamily="18" charset="0"/>
+              </a:rPr>
+              <a:t> </a:t>
+            </a:r>
+            <a:r>
+              <a:rPr lang="pt-BR" sz="2000" dirty="0" err="1">
+                <a:latin typeface="Times New Roman" panose="02020603050405020304" pitchFamily="18" charset="0"/>
+                <a:cs typeface="Times New Roman" panose="02020603050405020304" pitchFamily="18" charset="0"/>
+              </a:rPr>
+              <a:t>department</a:t>
+            </a:r>
+            <a:r>
+              <a:rPr lang="pt-BR" sz="2000" dirty="0">
+                <a:latin typeface="Times New Roman" panose="02020603050405020304" pitchFamily="18" charset="0"/>
+                <a:cs typeface="Times New Roman" panose="02020603050405020304" pitchFamily="18" charset="0"/>
+              </a:rPr>
+              <a:t> </a:t>
+            </a:r>
+            <a:r>
+              <a:rPr lang="pt-BR" sz="2000" b="1" dirty="0">
+                <a:latin typeface="Times New Roman" panose="02020603050405020304" pitchFamily="18" charset="0"/>
+                <a:cs typeface="Times New Roman" panose="02020603050405020304" pitchFamily="18" charset="0"/>
+              </a:rPr>
+              <a:t>set</a:t>
+            </a:r>
+            <a:r>
+              <a:rPr lang="pt-BR" sz="2000" dirty="0">
+                <a:latin typeface="Times New Roman" panose="02020603050405020304" pitchFamily="18" charset="0"/>
+                <a:cs typeface="Times New Roman" panose="02020603050405020304" pitchFamily="18" charset="0"/>
+              </a:rPr>
+              <a:t> </a:t>
+            </a:r>
+            <a:r>
+              <a:rPr lang="pt-BR" sz="2000" dirty="0" err="1">
+                <a:latin typeface="Times New Roman" panose="02020603050405020304" pitchFamily="18" charset="0"/>
+                <a:cs typeface="Times New Roman" panose="02020603050405020304" pitchFamily="18" charset="0"/>
+              </a:rPr>
+              <a:t>Name</a:t>
+            </a:r>
+            <a:r>
+              <a:rPr lang="pt-BR" sz="2000" dirty="0">
+                <a:latin typeface="Times New Roman" panose="02020603050405020304" pitchFamily="18" charset="0"/>
+                <a:cs typeface="Times New Roman" panose="02020603050405020304" pitchFamily="18" charset="0"/>
+              </a:rPr>
+              <a:t> = %s </a:t>
+            </a:r>
+            <a:r>
+              <a:rPr lang="pt-BR" sz="2000" b="1" dirty="0" err="1">
+                <a:latin typeface="Times New Roman" panose="02020603050405020304" pitchFamily="18" charset="0"/>
+                <a:cs typeface="Times New Roman" panose="02020603050405020304" pitchFamily="18" charset="0"/>
+              </a:rPr>
+              <a:t>where</a:t>
+            </a:r>
+            <a:r>
+              <a:rPr lang="pt-BR" sz="2000" dirty="0">
+                <a:latin typeface="Times New Roman" panose="02020603050405020304" pitchFamily="18" charset="0"/>
+                <a:cs typeface="Times New Roman" panose="02020603050405020304" pitchFamily="18" charset="0"/>
+              </a:rPr>
+              <a:t> Id = %s"</a:t>
+            </a:r>
+          </a:p>
+          <a:p>
+            <a:pPr marL="0" indent="0" algn="just">
+              <a:buNone/>
+            </a:pPr>
+            <a:r>
+              <a:rPr lang="pt-BR" sz="2000" dirty="0">
+                <a:latin typeface="Times New Roman" panose="02020603050405020304" pitchFamily="18" charset="0"/>
+                <a:cs typeface="Times New Roman" panose="02020603050405020304" pitchFamily="18" charset="0"/>
+              </a:rPr>
+              <a:t>valores = (nome, id)</a:t>
+            </a:r>
+          </a:p>
+          <a:p>
+            <a:pPr marL="0" indent="0" algn="just">
+              <a:buNone/>
+            </a:pPr>
+            <a:r>
+              <a:rPr lang="pt-BR" sz="2000" dirty="0" err="1">
+                <a:latin typeface="Times New Roman" panose="02020603050405020304" pitchFamily="18" charset="0"/>
+                <a:cs typeface="Times New Roman" panose="02020603050405020304" pitchFamily="18" charset="0"/>
+              </a:rPr>
+              <a:t>cursor.</a:t>
+            </a:r>
+            <a:r>
+              <a:rPr lang="pt-BR" sz="2000" b="1" dirty="0" err="1">
                 <a:solidFill>
                   <a:srgbClr val="FF0000"/>
                 </a:solidFill>
                 <a:latin typeface="Times New Roman" panose="02020603050405020304" pitchFamily="18" charset="0"/>
                 <a:cs typeface="Times New Roman" panose="02020603050405020304" pitchFamily="18" charset="0"/>
               </a:rPr>
-              <a:t>f</a:t>
-            </a:r>
-            <a:r>
-              <a:rPr lang="pt-BR" sz="2400" dirty="0" err="1">
-                <a:latin typeface="Times New Roman" panose="02020603050405020304" pitchFamily="18" charset="0"/>
-                <a:cs typeface="Times New Roman" panose="02020603050405020304" pitchFamily="18" charset="0"/>
-              </a:rPr>
-              <a:t>"</a:t>
-            </a:r>
-            <a:r>
-              <a:rPr lang="pt-BR" sz="2400" b="1" dirty="0" err="1">
-                <a:latin typeface="Times New Roman" panose="02020603050405020304" pitchFamily="18" charset="0"/>
-                <a:cs typeface="Times New Roman" panose="02020603050405020304" pitchFamily="18" charset="0"/>
-              </a:rPr>
-              <a:t>update</a:t>
-            </a:r>
-            <a:r>
-              <a:rPr lang="pt-BR" sz="2400" dirty="0">
-                <a:latin typeface="Times New Roman" panose="02020603050405020304" pitchFamily="18" charset="0"/>
-                <a:cs typeface="Times New Roman" panose="02020603050405020304" pitchFamily="18" charset="0"/>
-              </a:rPr>
-              <a:t> </a:t>
-            </a:r>
-            <a:r>
-              <a:rPr lang="pt-BR" sz="2400" dirty="0" err="1">
-                <a:latin typeface="Times New Roman" panose="02020603050405020304" pitchFamily="18" charset="0"/>
-                <a:cs typeface="Times New Roman" panose="02020603050405020304" pitchFamily="18" charset="0"/>
-              </a:rPr>
-              <a:t>department</a:t>
-            </a:r>
-            <a:r>
-              <a:rPr lang="pt-BR" sz="2400" dirty="0">
-                <a:latin typeface="Times New Roman" panose="02020603050405020304" pitchFamily="18" charset="0"/>
-                <a:cs typeface="Times New Roman" panose="02020603050405020304" pitchFamily="18" charset="0"/>
-              </a:rPr>
-              <a:t> </a:t>
-            </a:r>
-            <a:r>
-              <a:rPr lang="pt-BR" sz="2400" b="1" dirty="0">
-                <a:latin typeface="Times New Roman" panose="02020603050405020304" pitchFamily="18" charset="0"/>
-                <a:cs typeface="Times New Roman" panose="02020603050405020304" pitchFamily="18" charset="0"/>
-              </a:rPr>
-              <a:t>set</a:t>
-            </a:r>
-            <a:r>
-              <a:rPr lang="pt-BR" sz="2400" dirty="0">
-                <a:latin typeface="Times New Roman" panose="02020603050405020304" pitchFamily="18" charset="0"/>
-                <a:cs typeface="Times New Roman" panose="02020603050405020304" pitchFamily="18" charset="0"/>
-              </a:rPr>
-              <a:t> </a:t>
-            </a:r>
-            <a:r>
-              <a:rPr lang="pt-BR" sz="2400" dirty="0" err="1">
-                <a:latin typeface="Times New Roman" panose="02020603050405020304" pitchFamily="18" charset="0"/>
-                <a:cs typeface="Times New Roman" panose="02020603050405020304" pitchFamily="18" charset="0"/>
-              </a:rPr>
-              <a:t>Name</a:t>
-            </a:r>
-            <a:r>
-              <a:rPr lang="pt-BR" sz="2400" dirty="0">
-                <a:latin typeface="Times New Roman" panose="02020603050405020304" pitchFamily="18" charset="0"/>
-                <a:cs typeface="Times New Roman" panose="02020603050405020304" pitchFamily="18" charset="0"/>
-              </a:rPr>
-              <a:t> = '{nome}' </a:t>
-            </a:r>
-            <a:r>
-              <a:rPr lang="pt-BR" sz="2400" b="1" dirty="0" err="1">
-                <a:latin typeface="Times New Roman" panose="02020603050405020304" pitchFamily="18" charset="0"/>
-                <a:cs typeface="Times New Roman" panose="02020603050405020304" pitchFamily="18" charset="0"/>
-              </a:rPr>
-              <a:t>where</a:t>
-            </a:r>
-            <a:r>
-              <a:rPr lang="pt-BR" sz="2400" dirty="0">
-                <a:latin typeface="Times New Roman" panose="02020603050405020304" pitchFamily="18" charset="0"/>
-                <a:cs typeface="Times New Roman" panose="02020603050405020304" pitchFamily="18" charset="0"/>
-              </a:rPr>
-              <a:t> Id = {id}"</a:t>
+              <a:t>execute</a:t>
+            </a:r>
+            <a:r>
+              <a:rPr lang="pt-BR" sz="2000" dirty="0">
+                <a:latin typeface="Times New Roman" panose="02020603050405020304" pitchFamily="18" charset="0"/>
+                <a:cs typeface="Times New Roman" panose="02020603050405020304" pitchFamily="18" charset="0"/>
+              </a:rPr>
+              <a:t>(</a:t>
+            </a:r>
+            <a:r>
+              <a:rPr lang="pt-BR" sz="2000" dirty="0" err="1">
+                <a:latin typeface="Times New Roman" panose="02020603050405020304" pitchFamily="18" charset="0"/>
+                <a:cs typeface="Times New Roman" panose="02020603050405020304" pitchFamily="18" charset="0"/>
+              </a:rPr>
+              <a:t>sql</a:t>
+            </a:r>
+            <a:r>
+              <a:rPr lang="pt-BR" sz="2000" dirty="0">
+                <a:latin typeface="Times New Roman" panose="02020603050405020304" pitchFamily="18" charset="0"/>
+                <a:cs typeface="Times New Roman" panose="02020603050405020304" pitchFamily="18" charset="0"/>
+              </a:rPr>
+              <a:t>, valores)</a:t>
             </a:r>
           </a:p>
           <a:p>
             <a:pPr marL="0" indent="0" algn="just">
               <a:buNone/>
             </a:pPr>
-            <a:endParaRPr lang="pt-BR" sz="2400" dirty="0">
-              <a:latin typeface="Times New Roman" panose="02020603050405020304" pitchFamily="18" charset="0"/>
-              <a:cs typeface="Times New Roman" panose="02020603050405020304" pitchFamily="18" charset="0"/>
-            </a:endParaRPr>
+            <a:r>
+              <a:rPr lang="pt-BR" sz="2000" dirty="0" err="1">
+                <a:latin typeface="Times New Roman" panose="02020603050405020304" pitchFamily="18" charset="0"/>
+                <a:cs typeface="Times New Roman" panose="02020603050405020304" pitchFamily="18" charset="0"/>
+              </a:rPr>
+              <a:t>conn.</a:t>
+            </a:r>
+            <a:r>
+              <a:rPr lang="pt-BR" sz="2000" b="1" dirty="0" err="1">
+                <a:solidFill>
+                  <a:srgbClr val="FF0000"/>
+                </a:solidFill>
+                <a:latin typeface="Times New Roman" panose="02020603050405020304" pitchFamily="18" charset="0"/>
+                <a:cs typeface="Times New Roman" panose="02020603050405020304" pitchFamily="18" charset="0"/>
+              </a:rPr>
+              <a:t>commit</a:t>
+            </a:r>
+            <a:r>
+              <a:rPr lang="pt-BR" sz="2000" dirty="0">
+                <a:latin typeface="Times New Roman" panose="02020603050405020304" pitchFamily="18" charset="0"/>
+                <a:cs typeface="Times New Roman" panose="02020603050405020304" pitchFamily="18" charset="0"/>
+              </a:rPr>
+              <a:t>()</a:t>
+            </a:r>
           </a:p>
           <a:p>
             <a:pPr marL="0" indent="0" algn="just">
               <a:buNone/>
             </a:pPr>
             <a:r>
-              <a:rPr lang="pt-BR" sz="2400" dirty="0" err="1">
-                <a:latin typeface="Times New Roman" panose="02020603050405020304" pitchFamily="18" charset="0"/>
-                <a:cs typeface="Times New Roman" panose="02020603050405020304" pitchFamily="18" charset="0"/>
-              </a:rPr>
-              <a:t>cursor.</a:t>
-            </a:r>
-            <a:r>
-              <a:rPr lang="pt-BR" sz="2400" b="1" dirty="0" err="1">
-                <a:solidFill>
-                  <a:srgbClr val="FF0000"/>
-                </a:solidFill>
-                <a:latin typeface="Times New Roman" panose="02020603050405020304" pitchFamily="18" charset="0"/>
-                <a:cs typeface="Times New Roman" panose="02020603050405020304" pitchFamily="18" charset="0"/>
-              </a:rPr>
-              <a:t>execute</a:t>
-            </a:r>
-            <a:r>
-              <a:rPr lang="pt-BR" sz="2400" dirty="0">
-                <a:latin typeface="Times New Roman" panose="02020603050405020304" pitchFamily="18" charset="0"/>
-                <a:cs typeface="Times New Roman" panose="02020603050405020304" pitchFamily="18" charset="0"/>
-              </a:rPr>
-              <a:t>(</a:t>
-            </a:r>
-            <a:r>
-              <a:rPr lang="pt-BR" sz="2400" dirty="0" err="1">
-                <a:latin typeface="Times New Roman" panose="02020603050405020304" pitchFamily="18" charset="0"/>
-                <a:cs typeface="Times New Roman" panose="02020603050405020304" pitchFamily="18" charset="0"/>
-              </a:rPr>
-              <a:t>sql</a:t>
-            </a:r>
-            <a:r>
-              <a:rPr lang="pt-BR" sz="2400" dirty="0">
-                <a:latin typeface="Times New Roman" panose="02020603050405020304" pitchFamily="18" charset="0"/>
-                <a:cs typeface="Times New Roman" panose="02020603050405020304" pitchFamily="18" charset="0"/>
-              </a:rPr>
-              <a:t>)</a:t>
-            </a:r>
-          </a:p>
-          <a:p>
-            <a:pPr marL="0" indent="0" algn="just">
-              <a:buNone/>
-            </a:pPr>
-            <a:r>
-              <a:rPr lang="pt-BR" sz="2400" dirty="0" err="1">
-                <a:latin typeface="Times New Roman" panose="02020603050405020304" pitchFamily="18" charset="0"/>
-                <a:cs typeface="Times New Roman" panose="02020603050405020304" pitchFamily="18" charset="0"/>
-              </a:rPr>
-              <a:t>conn.</a:t>
-            </a:r>
-            <a:r>
-              <a:rPr lang="pt-BR" sz="2400" b="1" dirty="0" err="1">
-                <a:solidFill>
-                  <a:srgbClr val="FF0000"/>
-                </a:solidFill>
-                <a:latin typeface="Times New Roman" panose="02020603050405020304" pitchFamily="18" charset="0"/>
-                <a:cs typeface="Times New Roman" panose="02020603050405020304" pitchFamily="18" charset="0"/>
-              </a:rPr>
-              <a:t>commit</a:t>
-            </a:r>
-            <a:r>
-              <a:rPr lang="pt-BR" sz="2400" dirty="0">
-                <a:latin typeface="Times New Roman" panose="02020603050405020304" pitchFamily="18" charset="0"/>
-                <a:cs typeface="Times New Roman" panose="02020603050405020304" pitchFamily="18" charset="0"/>
-              </a:rPr>
-              <a:t>()</a:t>
-            </a:r>
-          </a:p>
-          <a:p>
-            <a:pPr marL="0" indent="0" algn="just">
-              <a:buNone/>
-            </a:pPr>
-            <a:r>
-              <a:rPr lang="pt-BR" sz="2400" b="1" dirty="0">
+              <a:rPr lang="pt-BR" sz="2000" b="1" dirty="0">
                 <a:latin typeface="Times New Roman" panose="02020603050405020304" pitchFamily="18" charset="0"/>
                 <a:cs typeface="Times New Roman" panose="02020603050405020304" pitchFamily="18" charset="0"/>
               </a:rPr>
               <a:t>print</a:t>
             </a:r>
             <a:r>
-              <a:rPr lang="pt-BR" sz="2400" dirty="0">
+              <a:rPr lang="pt-BR" sz="2000" dirty="0">
                 <a:latin typeface="Times New Roman" panose="02020603050405020304" pitchFamily="18" charset="0"/>
                 <a:cs typeface="Times New Roman" panose="02020603050405020304" pitchFamily="18" charset="0"/>
               </a:rPr>
               <a:t>("Atualizado com sucesso")</a:t>
             </a:r>
-            <a:endParaRPr lang="pt-BR" sz="2400" dirty="0">
+            <a:endParaRPr lang="pt-BR" sz="2000" dirty="0">
               <a:solidFill>
                 <a:schemeClr val="tx1"/>
               </a:solidFill>
@@ -5849,7 +5842,7 @@
               <a:buNone/>
             </a:pPr>
             <a:r>
-              <a:rPr lang="pt-BR" sz="2400" dirty="0">
+              <a:rPr lang="pt-BR" sz="2000" dirty="0">
                 <a:solidFill>
                   <a:schemeClr val="tx1"/>
                 </a:solidFill>
@@ -5859,7 +5852,7 @@
               <a:t>cursor = </a:t>
             </a:r>
             <a:r>
-              <a:rPr lang="pt-BR" sz="2400" dirty="0" err="1">
+              <a:rPr lang="pt-BR" sz="2000" dirty="0" err="1">
                 <a:solidFill>
                   <a:schemeClr val="tx1"/>
                 </a:solidFill>
@@ -5869,7 +5862,7 @@
               <a:t>conn.</a:t>
             </a:r>
             <a:r>
-              <a:rPr lang="pt-BR" sz="2400" b="1" dirty="0" err="1">
+              <a:rPr lang="pt-BR" sz="2000" b="1" dirty="0" err="1">
                 <a:solidFill>
                   <a:srgbClr val="FF0000"/>
                 </a:solidFill>
@@ -5879,7 +5872,7 @@
               <a:t>cursor</a:t>
             </a:r>
             <a:r>
-              <a:rPr lang="pt-BR" sz="2400" dirty="0">
+              <a:rPr lang="pt-BR" sz="2000" dirty="0">
                 <a:solidFill>
                   <a:schemeClr val="tx1"/>
                 </a:solidFill>
@@ -5894,13 +5887,13 @@
               <a:buNone/>
             </a:pPr>
             <a:r>
-              <a:rPr lang="pt-BR" sz="2400" dirty="0">
+              <a:rPr lang="pt-BR" sz="2000" dirty="0">
                 <a:latin typeface="Times New Roman" panose="02020603050405020304" pitchFamily="18" charset="0"/>
                 <a:cs typeface="Times New Roman" panose="02020603050405020304" pitchFamily="18" charset="0"/>
               </a:rPr>
               <a:t>id = 63</a:t>
             </a:r>
-            <a:endParaRPr lang="pt-BR" sz="2400" dirty="0">
+            <a:endParaRPr lang="pt-BR" sz="2000" dirty="0">
               <a:solidFill>
                 <a:schemeClr val="tx1"/>
               </a:solidFill>
@@ -5913,91 +5906,252 @@
               <a:buNone/>
             </a:pPr>
             <a:r>
-              <a:rPr lang="pt-BR" sz="2400" dirty="0" err="1">
+              <a:rPr lang="pt-BR" sz="2000" dirty="0" err="1">
                 <a:latin typeface="Times New Roman" panose="02020603050405020304" pitchFamily="18" charset="0"/>
                 <a:cs typeface="Times New Roman" panose="02020603050405020304" pitchFamily="18" charset="0"/>
               </a:rPr>
               <a:t>sql</a:t>
             </a:r>
             <a:r>
-              <a:rPr lang="pt-BR" sz="2400" dirty="0">
-                <a:latin typeface="Times New Roman" panose="02020603050405020304" pitchFamily="18" charset="0"/>
-                <a:cs typeface="Times New Roman" panose="02020603050405020304" pitchFamily="18" charset="0"/>
-              </a:rPr>
-              <a:t> = </a:t>
-            </a:r>
-            <a:r>
-              <a:rPr lang="pt-BR" sz="2400" b="1" dirty="0" err="1">
+              <a:rPr lang="pt-BR" sz="2000" dirty="0">
+                <a:latin typeface="Times New Roman" panose="02020603050405020304" pitchFamily="18" charset="0"/>
+                <a:cs typeface="Times New Roman" panose="02020603050405020304" pitchFamily="18" charset="0"/>
+              </a:rPr>
+              <a:t> =  "</a:t>
+            </a:r>
+            <a:r>
+              <a:rPr lang="pt-BR" sz="2000" b="1" dirty="0">
+                <a:latin typeface="Times New Roman" panose="02020603050405020304" pitchFamily="18" charset="0"/>
+                <a:cs typeface="Times New Roman" panose="02020603050405020304" pitchFamily="18" charset="0"/>
+              </a:rPr>
+              <a:t>delete</a:t>
+            </a:r>
+            <a:r>
+              <a:rPr lang="pt-BR" sz="2000" dirty="0">
+                <a:latin typeface="Times New Roman" panose="02020603050405020304" pitchFamily="18" charset="0"/>
+                <a:cs typeface="Times New Roman" panose="02020603050405020304" pitchFamily="18" charset="0"/>
+              </a:rPr>
+              <a:t> </a:t>
+            </a:r>
+            <a:r>
+              <a:rPr lang="pt-BR" sz="2000" b="1" dirty="0" err="1">
+                <a:latin typeface="Times New Roman" panose="02020603050405020304" pitchFamily="18" charset="0"/>
+                <a:cs typeface="Times New Roman" panose="02020603050405020304" pitchFamily="18" charset="0"/>
+              </a:rPr>
+              <a:t>from</a:t>
+            </a:r>
+            <a:r>
+              <a:rPr lang="pt-BR" sz="2000" b="1" dirty="0">
+                <a:latin typeface="Times New Roman" panose="02020603050405020304" pitchFamily="18" charset="0"/>
+                <a:cs typeface="Times New Roman" panose="02020603050405020304" pitchFamily="18" charset="0"/>
+              </a:rPr>
+              <a:t> </a:t>
+            </a:r>
+            <a:r>
+              <a:rPr lang="pt-BR" sz="2000" dirty="0" err="1">
+                <a:latin typeface="Times New Roman" panose="02020603050405020304" pitchFamily="18" charset="0"/>
+                <a:cs typeface="Times New Roman" panose="02020603050405020304" pitchFamily="18" charset="0"/>
+              </a:rPr>
+              <a:t>department</a:t>
+            </a:r>
+            <a:r>
+              <a:rPr lang="pt-BR" sz="2000" dirty="0">
+                <a:latin typeface="Times New Roman" panose="02020603050405020304" pitchFamily="18" charset="0"/>
+                <a:cs typeface="Times New Roman" panose="02020603050405020304" pitchFamily="18" charset="0"/>
+              </a:rPr>
+              <a:t> </a:t>
+            </a:r>
+            <a:r>
+              <a:rPr lang="pt-BR" sz="2000" b="1" dirty="0" err="1">
+                <a:latin typeface="Times New Roman" panose="02020603050405020304" pitchFamily="18" charset="0"/>
+                <a:cs typeface="Times New Roman" panose="02020603050405020304" pitchFamily="18" charset="0"/>
+              </a:rPr>
+              <a:t>where</a:t>
+            </a:r>
+            <a:r>
+              <a:rPr lang="pt-BR" sz="2000" dirty="0">
+                <a:latin typeface="Times New Roman" panose="02020603050405020304" pitchFamily="18" charset="0"/>
+                <a:cs typeface="Times New Roman" panose="02020603050405020304" pitchFamily="18" charset="0"/>
+              </a:rPr>
+              <a:t> Id = %s"</a:t>
+            </a:r>
+          </a:p>
+          <a:p>
+            <a:pPr marL="0" indent="0" algn="just">
+              <a:buNone/>
+            </a:pPr>
+            <a:r>
+              <a:rPr lang="pt-BR" sz="2000" dirty="0">
+                <a:latin typeface="Times New Roman" panose="02020603050405020304" pitchFamily="18" charset="0"/>
+                <a:cs typeface="Times New Roman" panose="02020603050405020304" pitchFamily="18" charset="0"/>
+              </a:rPr>
+              <a:t>valor = (id,)</a:t>
+            </a:r>
+          </a:p>
+          <a:p>
+            <a:pPr marL="0" indent="0" algn="just">
+              <a:buNone/>
+            </a:pPr>
+            <a:r>
+              <a:rPr lang="pt-BR" sz="2000" dirty="0" err="1">
+                <a:latin typeface="Times New Roman" panose="02020603050405020304" pitchFamily="18" charset="0"/>
+                <a:cs typeface="Times New Roman" panose="02020603050405020304" pitchFamily="18" charset="0"/>
+              </a:rPr>
+              <a:t>cursor.</a:t>
+            </a:r>
+            <a:r>
+              <a:rPr lang="pt-BR" sz="2000" b="1" dirty="0" err="1">
                 <a:solidFill>
                   <a:srgbClr val="FF0000"/>
                 </a:solidFill>
                 <a:latin typeface="Times New Roman" panose="02020603050405020304" pitchFamily="18" charset="0"/>
                 <a:cs typeface="Times New Roman" panose="02020603050405020304" pitchFamily="18" charset="0"/>
               </a:rPr>
-              <a:t>f</a:t>
-            </a:r>
-            <a:r>
-              <a:rPr lang="pt-BR" sz="2400" dirty="0" err="1">
-                <a:latin typeface="Times New Roman" panose="02020603050405020304" pitchFamily="18" charset="0"/>
-                <a:cs typeface="Times New Roman" panose="02020603050405020304" pitchFamily="18" charset="0"/>
-              </a:rPr>
-              <a:t>“</a:t>
-            </a:r>
-            <a:r>
-              <a:rPr lang="pt-BR" sz="2400" b="1" dirty="0" err="1">
-                <a:latin typeface="Times New Roman" panose="02020603050405020304" pitchFamily="18" charset="0"/>
-                <a:cs typeface="Times New Roman" panose="02020603050405020304" pitchFamily="18" charset="0"/>
-              </a:rPr>
-              <a:t>delete</a:t>
-            </a:r>
-            <a:r>
-              <a:rPr lang="pt-BR" sz="2400" dirty="0">
+              <a:t>execute</a:t>
+            </a:r>
+            <a:r>
+              <a:rPr lang="pt-BR" sz="2000" dirty="0">
+                <a:latin typeface="Times New Roman" panose="02020603050405020304" pitchFamily="18" charset="0"/>
+                <a:cs typeface="Times New Roman" panose="02020603050405020304" pitchFamily="18" charset="0"/>
+              </a:rPr>
+              <a:t>(</a:t>
+            </a:r>
+            <a:r>
+              <a:rPr lang="pt-BR" sz="2000" dirty="0" err="1">
+                <a:latin typeface="Times New Roman" panose="02020603050405020304" pitchFamily="18" charset="0"/>
+                <a:cs typeface="Times New Roman" panose="02020603050405020304" pitchFamily="18" charset="0"/>
+              </a:rPr>
+              <a:t>sql</a:t>
+            </a:r>
+            <a:r>
+              <a:rPr lang="pt-BR" sz="2000" dirty="0">
+                <a:latin typeface="Times New Roman" panose="02020603050405020304" pitchFamily="18" charset="0"/>
+                <a:cs typeface="Times New Roman" panose="02020603050405020304" pitchFamily="18" charset="0"/>
+              </a:rPr>
+              <a:t>, valor)</a:t>
+            </a:r>
+          </a:p>
+          <a:p>
+            <a:pPr marL="0" indent="0" algn="just">
+              <a:buNone/>
+            </a:pPr>
+            <a:r>
+              <a:rPr lang="pt-BR" sz="2000" dirty="0">
+                <a:latin typeface="Times New Roman" panose="02020603050405020304" pitchFamily="18" charset="0"/>
+                <a:cs typeface="Times New Roman" panose="02020603050405020304" pitchFamily="18" charset="0"/>
+              </a:rPr>
+              <a:t>linha = </a:t>
+            </a:r>
+            <a:r>
+              <a:rPr lang="pt-BR" sz="2000" dirty="0" err="1">
+                <a:solidFill>
+                  <a:schemeClr val="tx1"/>
+                </a:solidFill>
+                <a:latin typeface="Times New Roman" panose="02020603050405020304" pitchFamily="18" charset="0"/>
+                <a:cs typeface="Times New Roman" panose="02020603050405020304" pitchFamily="18" charset="0"/>
+              </a:rPr>
+              <a:t>cursor.</a:t>
+            </a:r>
+            <a:r>
+              <a:rPr lang="pt-BR" sz="2000" b="1" dirty="0" err="1">
+                <a:solidFill>
+                  <a:srgbClr val="FF0000"/>
+                </a:solidFill>
+                <a:latin typeface="Times New Roman" panose="02020603050405020304" pitchFamily="18" charset="0"/>
+                <a:cs typeface="Times New Roman" panose="02020603050405020304" pitchFamily="18" charset="0"/>
+              </a:rPr>
+              <a:t>fetchone</a:t>
+            </a:r>
+            <a:r>
+              <a:rPr lang="pt-BR" sz="2000" dirty="0">
+                <a:solidFill>
+                  <a:schemeClr val="tx1"/>
+                </a:solidFill>
+                <a:latin typeface="Times New Roman" panose="02020603050405020304" pitchFamily="18" charset="0"/>
+                <a:cs typeface="Times New Roman" panose="02020603050405020304" pitchFamily="18" charset="0"/>
+              </a:rPr>
+              <a:t>()</a:t>
+            </a:r>
+          </a:p>
+          <a:p>
+            <a:pPr marL="0" indent="0" algn="just">
+              <a:buNone/>
+            </a:pPr>
+            <a:r>
+              <a:rPr lang="pt-BR" sz="2000" dirty="0" err="1">
+                <a:latin typeface="Times New Roman" panose="02020603050405020304" pitchFamily="18" charset="0"/>
+                <a:cs typeface="Times New Roman" panose="02020603050405020304" pitchFamily="18" charset="0"/>
+              </a:rPr>
+              <a:t>if</a:t>
+            </a:r>
+            <a:r>
+              <a:rPr lang="pt-BR" sz="2000" dirty="0">
+                <a:latin typeface="Times New Roman" panose="02020603050405020304" pitchFamily="18" charset="0"/>
+                <a:cs typeface="Times New Roman" panose="02020603050405020304" pitchFamily="18" charset="0"/>
+              </a:rPr>
+              <a:t> (linha </a:t>
+            </a:r>
+            <a:r>
+              <a:rPr lang="pt-BR" sz="2000" b="1" dirty="0" err="1">
+                <a:latin typeface="Times New Roman" panose="02020603050405020304" pitchFamily="18" charset="0"/>
+                <a:cs typeface="Times New Roman" panose="02020603050405020304" pitchFamily="18" charset="0"/>
+              </a:rPr>
+              <a:t>is</a:t>
+            </a:r>
+            <a:r>
+              <a:rPr lang="pt-BR" sz="2000" b="1" dirty="0">
                 <a:latin typeface="Times New Roman" panose="02020603050405020304" pitchFamily="18" charset="0"/>
                 <a:cs typeface="Times New Roman" panose="02020603050405020304" pitchFamily="18" charset="0"/>
               </a:rPr>
               <a:t> </a:t>
             </a:r>
             <a:r>
-              <a:rPr lang="pt-BR" sz="2400" b="1" dirty="0" err="1">
-                <a:latin typeface="Times New Roman" panose="02020603050405020304" pitchFamily="18" charset="0"/>
-                <a:cs typeface="Times New Roman" panose="02020603050405020304" pitchFamily="18" charset="0"/>
-              </a:rPr>
-              <a:t>from</a:t>
-            </a:r>
-            <a:r>
-              <a:rPr lang="pt-BR" sz="2400" b="1" dirty="0">
+              <a:rPr lang="pt-BR" sz="2000" b="1" dirty="0" err="1">
+                <a:latin typeface="Times New Roman" panose="02020603050405020304" pitchFamily="18" charset="0"/>
+                <a:cs typeface="Times New Roman" panose="02020603050405020304" pitchFamily="18" charset="0"/>
+              </a:rPr>
+              <a:t>not</a:t>
+            </a:r>
+            <a:r>
+              <a:rPr lang="pt-BR" sz="2000" b="1" dirty="0">
                 <a:latin typeface="Times New Roman" panose="02020603050405020304" pitchFamily="18" charset="0"/>
                 <a:cs typeface="Times New Roman" panose="02020603050405020304" pitchFamily="18" charset="0"/>
               </a:rPr>
               <a:t> </a:t>
             </a:r>
             <a:r>
-              <a:rPr lang="pt-BR" sz="2400" dirty="0" err="1">
-                <a:latin typeface="Times New Roman" panose="02020603050405020304" pitchFamily="18" charset="0"/>
-                <a:cs typeface="Times New Roman" panose="02020603050405020304" pitchFamily="18" charset="0"/>
-              </a:rPr>
-              <a:t>department</a:t>
-            </a:r>
-            <a:r>
-              <a:rPr lang="pt-BR" sz="2400" dirty="0">
-                <a:latin typeface="Times New Roman" panose="02020603050405020304" pitchFamily="18" charset="0"/>
-                <a:cs typeface="Times New Roman" panose="02020603050405020304" pitchFamily="18" charset="0"/>
-              </a:rPr>
-              <a:t> </a:t>
-            </a:r>
-            <a:r>
-              <a:rPr lang="pt-BR" sz="2400" b="1" dirty="0" err="1">
-                <a:latin typeface="Times New Roman" panose="02020603050405020304" pitchFamily="18" charset="0"/>
-                <a:cs typeface="Times New Roman" panose="02020603050405020304" pitchFamily="18" charset="0"/>
-              </a:rPr>
-              <a:t>where</a:t>
-            </a:r>
-            <a:r>
-              <a:rPr lang="pt-BR" sz="2400" dirty="0">
-                <a:latin typeface="Times New Roman" panose="02020603050405020304" pitchFamily="18" charset="0"/>
-                <a:cs typeface="Times New Roman" panose="02020603050405020304" pitchFamily="18" charset="0"/>
-              </a:rPr>
-              <a:t> Id = {id}"</a:t>
+              <a:rPr lang="pt-BR" sz="2000" dirty="0" err="1">
+                <a:latin typeface="Times New Roman" panose="02020603050405020304" pitchFamily="18" charset="0"/>
+                <a:cs typeface="Times New Roman" panose="02020603050405020304" pitchFamily="18" charset="0"/>
+              </a:rPr>
+              <a:t>None</a:t>
+            </a:r>
+            <a:r>
+              <a:rPr lang="pt-BR" sz="2000" dirty="0">
+                <a:latin typeface="Times New Roman" panose="02020603050405020304" pitchFamily="18" charset="0"/>
+                <a:cs typeface="Times New Roman" panose="02020603050405020304" pitchFamily="18" charset="0"/>
+              </a:rPr>
+              <a:t>): # ou </a:t>
+            </a:r>
+            <a:r>
+              <a:rPr lang="pt-BR" sz="2000" b="1" dirty="0" err="1">
+                <a:solidFill>
+                  <a:srgbClr val="FF0000"/>
+                </a:solidFill>
+                <a:latin typeface="Times New Roman" panose="02020603050405020304" pitchFamily="18" charset="0"/>
+                <a:cs typeface="Times New Roman" panose="02020603050405020304" pitchFamily="18" charset="0"/>
+              </a:rPr>
+              <a:t>linha.rowcount</a:t>
+            </a:r>
+            <a:r>
+              <a:rPr lang="pt-BR" sz="2000" b="1" dirty="0">
+                <a:solidFill>
+                  <a:srgbClr val="FF0000"/>
+                </a:solidFill>
+                <a:latin typeface="Times New Roman" panose="02020603050405020304" pitchFamily="18" charset="0"/>
+                <a:cs typeface="Times New Roman" panose="02020603050405020304" pitchFamily="18" charset="0"/>
+              </a:rPr>
+              <a:t> &gt; 0:</a:t>
             </a:r>
           </a:p>
           <a:p>
@@ -6005,42 +6159,35 @@
               <a:buNone/>
             </a:pPr>
             <a:r>
-              <a:rPr lang="pt-BR" sz="2400" dirty="0" err="1">
-                <a:latin typeface="Times New Roman" panose="02020603050405020304" pitchFamily="18" charset="0"/>
-                <a:cs typeface="Times New Roman" panose="02020603050405020304" pitchFamily="18" charset="0"/>
-              </a:rPr>
-              <a:t>cursor.</a:t>
-            </a:r>
-            <a:r>
-              <a:rPr lang="pt-BR" sz="2400" b="1" dirty="0" err="1">
+              <a:rPr lang="pt-BR" sz="2000" dirty="0">
+                <a:latin typeface="Times New Roman" panose="02020603050405020304" pitchFamily="18" charset="0"/>
+                <a:cs typeface="Times New Roman" panose="02020603050405020304" pitchFamily="18" charset="0"/>
+              </a:rPr>
+              <a:t>    </a:t>
+            </a:r>
+            <a:r>
+              <a:rPr lang="pt-BR" sz="2000" dirty="0" err="1">
+                <a:latin typeface="Times New Roman" panose="02020603050405020304" pitchFamily="18" charset="0"/>
+                <a:cs typeface="Times New Roman" panose="02020603050405020304" pitchFamily="18" charset="0"/>
+              </a:rPr>
+              <a:t>conn.</a:t>
+            </a:r>
+            <a:r>
+              <a:rPr lang="pt-BR" sz="2000" b="1" dirty="0" err="1">
                 <a:solidFill>
                   <a:srgbClr val="FF0000"/>
                 </a:solidFill>
                 <a:latin typeface="Times New Roman" panose="02020603050405020304" pitchFamily="18" charset="0"/>
                 <a:cs typeface="Times New Roman" panose="02020603050405020304" pitchFamily="18" charset="0"/>
               </a:rPr>
-              <a:t>execute</a:t>
-            </a:r>
-            <a:r>
-              <a:rPr lang="pt-BR" sz="2400" dirty="0">
-                <a:latin typeface="Times New Roman" panose="02020603050405020304" pitchFamily="18" charset="0"/>
-                <a:cs typeface="Times New Roman" panose="02020603050405020304" pitchFamily="18" charset="0"/>
-              </a:rPr>
-              <a:t>(</a:t>
-            </a:r>
-            <a:r>
-              <a:rPr lang="pt-BR" sz="2400" dirty="0" err="1">
-                <a:latin typeface="Times New Roman" panose="02020603050405020304" pitchFamily="18" charset="0"/>
-                <a:cs typeface="Times New Roman" panose="02020603050405020304" pitchFamily="18" charset="0"/>
-              </a:rPr>
-              <a:t>sql</a:t>
-            </a:r>
-            <a:r>
-              <a:rPr lang="pt-BR" sz="2400" dirty="0">
-                <a:latin typeface="Times New Roman" panose="02020603050405020304" pitchFamily="18" charset="0"/>
-                <a:cs typeface="Times New Roman" panose="02020603050405020304" pitchFamily="18" charset="0"/>
-              </a:rPr>
-              <a:t>)</a:t>
+              <a:t>commit</a:t>
+            </a:r>
+            <a:r>
+              <a:rPr lang="pt-BR" sz="2000" dirty="0">
+                <a:latin typeface="Times New Roman" panose="02020603050405020304" pitchFamily="18" charset="0"/>
+                <a:cs typeface="Times New Roman" panose="02020603050405020304" pitchFamily="18" charset="0"/>
+              </a:rPr>
+              <a:t>()</a:t>
             </a:r>
           </a:p>
           <a:p>
@@ -6048,151 +6195,20 @@
               <a:buNone/>
             </a:pPr>
             <a:r>
-              <a:rPr lang="pt-BR" sz="2400" dirty="0">
-                <a:latin typeface="Times New Roman" panose="02020603050405020304" pitchFamily="18" charset="0"/>
-                <a:cs typeface="Times New Roman" panose="02020603050405020304" pitchFamily="18" charset="0"/>
-              </a:rPr>
-              <a:t>linha = </a:t>
-            </a:r>
-            <a:r>
-              <a:rPr lang="pt-BR" sz="2400" dirty="0" err="1">
-                <a:solidFill>
-                  <a:schemeClr val="tx1"/>
-                </a:solidFill>
-                <a:latin typeface="Times New Roman" panose="02020603050405020304" pitchFamily="18" charset="0"/>
-                <a:cs typeface="Times New Roman" panose="02020603050405020304" pitchFamily="18" charset="0"/>
-              </a:rPr>
-              <a:t>cursor.</a:t>
-            </a:r>
-            <a:r>
-              <a:rPr lang="pt-BR" sz="2400" b="1" dirty="0" err="1">
-                <a:solidFill>
-                  <a:srgbClr val="FF0000"/>
-                </a:solidFill>
-                <a:latin typeface="Times New Roman" panose="02020603050405020304" pitchFamily="18" charset="0"/>
-                <a:cs typeface="Times New Roman" panose="02020603050405020304" pitchFamily="18" charset="0"/>
-              </a:rPr>
-              <a:t>fetchone</a:t>
-            </a:r>
-            <a:r>
-              <a:rPr lang="pt-BR" sz="2400" dirty="0">
-                <a:solidFill>
-                  <a:schemeClr val="tx1"/>
-                </a:solidFill>
-                <a:latin typeface="Times New Roman" panose="02020603050405020304" pitchFamily="18" charset="0"/>
-                <a:cs typeface="Times New Roman" panose="02020603050405020304" pitchFamily="18" charset="0"/>
-              </a:rPr>
-              <a:t>()</a:t>
-            </a:r>
-          </a:p>
-          <a:p>
-            <a:pPr marL="0" indent="0" algn="just">
-              <a:buNone/>
-            </a:pPr>
-            <a:r>
-              <a:rPr lang="pt-BR" sz="2400" dirty="0" err="1">
-                <a:latin typeface="Times New Roman" panose="02020603050405020304" pitchFamily="18" charset="0"/>
-                <a:cs typeface="Times New Roman" panose="02020603050405020304" pitchFamily="18" charset="0"/>
-              </a:rPr>
-              <a:t>if</a:t>
-            </a:r>
-            <a:r>
-              <a:rPr lang="pt-BR" sz="2400" dirty="0">
-                <a:latin typeface="Times New Roman" panose="02020603050405020304" pitchFamily="18" charset="0"/>
-                <a:cs typeface="Times New Roman" panose="02020603050405020304" pitchFamily="18" charset="0"/>
-              </a:rPr>
-              <a:t> (linha != </a:t>
-            </a:r>
-            <a:r>
-              <a:rPr lang="pt-BR" sz="2400" dirty="0" err="1">
-                <a:latin typeface="Times New Roman" panose="02020603050405020304" pitchFamily="18" charset="0"/>
-                <a:cs typeface="Times New Roman" panose="02020603050405020304" pitchFamily="18" charset="0"/>
-              </a:rPr>
-              <a:t>None</a:t>
-            </a:r>
-            <a:r>
-              <a:rPr lang="pt-BR" sz="2400" dirty="0">
-                <a:latin typeface="Times New Roman" panose="02020603050405020304" pitchFamily="18" charset="0"/>
-                <a:cs typeface="Times New Roman" panose="02020603050405020304" pitchFamily="18" charset="0"/>
-              </a:rPr>
-              <a:t>): # ou </a:t>
-            </a:r>
-            <a:r>
-              <a:rPr lang="pt-BR" sz="2400" b="1" dirty="0" err="1">
-                <a:solidFill>
-                  <a:srgbClr val="FF0000"/>
-                </a:solidFill>
-                <a:latin typeface="Times New Roman" panose="02020603050405020304" pitchFamily="18" charset="0"/>
-                <a:cs typeface="Times New Roman" panose="02020603050405020304" pitchFamily="18" charset="0"/>
-              </a:rPr>
-              <a:t>linha.rowcount</a:t>
-            </a:r>
-            <a:r>
-              <a:rPr lang="pt-BR" sz="2400" b="1" dirty="0">
-                <a:solidFill>
-                  <a:srgbClr val="FF0000"/>
-                </a:solidFill>
-                <a:latin typeface="Times New Roman" panose="02020603050405020304" pitchFamily="18" charset="0"/>
-                <a:cs typeface="Times New Roman" panose="02020603050405020304" pitchFamily="18" charset="0"/>
-              </a:rPr>
-              <a:t> &gt; 0:</a:t>
-            </a:r>
-          </a:p>
-          <a:p>
-            <a:pPr marL="0" indent="0" algn="just">
-              <a:buNone/>
-            </a:pPr>
-            <a:r>
-              <a:rPr lang="pt-BR" sz="2400" dirty="0">
-                <a:latin typeface="Times New Roman" panose="02020603050405020304" pitchFamily="18" charset="0"/>
-                <a:cs typeface="Times New Roman" panose="02020603050405020304" pitchFamily="18" charset="0"/>
-              </a:rPr>
-              <a:t>    </a:t>
-            </a:r>
-            <a:r>
-              <a:rPr lang="pt-BR" sz="2400" dirty="0" err="1">
-                <a:latin typeface="Times New Roman" panose="02020603050405020304" pitchFamily="18" charset="0"/>
-                <a:cs typeface="Times New Roman" panose="02020603050405020304" pitchFamily="18" charset="0"/>
-              </a:rPr>
-              <a:t>conn.</a:t>
-            </a:r>
-            <a:r>
-              <a:rPr lang="pt-BR" sz="2400" b="1" dirty="0" err="1">
-                <a:solidFill>
-                  <a:srgbClr val="FF0000"/>
-                </a:solidFill>
-                <a:latin typeface="Times New Roman" panose="02020603050405020304" pitchFamily="18" charset="0"/>
-                <a:cs typeface="Times New Roman" panose="02020603050405020304" pitchFamily="18" charset="0"/>
-              </a:rPr>
-              <a:t>commit</a:t>
-            </a:r>
-            <a:r>
-              <a:rPr lang="pt-BR" sz="2400" dirty="0">
-                <a:latin typeface="Times New Roman" panose="02020603050405020304" pitchFamily="18" charset="0"/>
-                <a:cs typeface="Times New Roman" panose="02020603050405020304" pitchFamily="18" charset="0"/>
-              </a:rPr>
-              <a:t>()</a:t>
-            </a:r>
-          </a:p>
-          <a:p>
-            <a:pPr marL="0" indent="0" algn="just">
-              <a:buNone/>
-            </a:pPr>
-            <a:r>
-              <a:rPr lang="pt-BR" sz="2400" b="1" dirty="0">
+              <a:rPr lang="pt-BR" sz="2000" b="1" dirty="0">
                 <a:latin typeface="Times New Roman" panose="02020603050405020304" pitchFamily="18" charset="0"/>
                 <a:cs typeface="Times New Roman" panose="02020603050405020304" pitchFamily="18" charset="0"/>
               </a:rPr>
               <a:t>    print</a:t>
             </a:r>
             <a:r>
-              <a:rPr lang="pt-BR" sz="2400" dirty="0">
-                <a:latin typeface="Times New Roman" panose="02020603050405020304" pitchFamily="18" charset="0"/>
-                <a:cs typeface="Times New Roman" panose="02020603050405020304" pitchFamily="18" charset="0"/>
-              </a:rPr>
-              <a:t>(“Excluído com sucesso")</a:t>
-            </a:r>
-            <a:endParaRPr lang="pt-BR" sz="2400" dirty="0">
+              <a:rPr lang="pt-BR" sz="2000" dirty="0">
+                <a:latin typeface="Times New Roman" panose="02020603050405020304" pitchFamily="18" charset="0"/>
+                <a:cs typeface="Times New Roman" panose="02020603050405020304" pitchFamily="18" charset="0"/>
+              </a:rPr>
+              <a:t>("Excluído com sucesso")</a:t>
+            </a:r>
+            <a:endParaRPr lang="pt-BR" sz="2000" dirty="0">
               <a:solidFill>
                 <a:schemeClr val="tx1"/>
               </a:solidFill>
@@ -8470,7 +8486,7 @@
               <a:buNone/>
             </a:pPr>
             <a:r>
-              <a:rPr lang="pt-BR" sz="2000" dirty="0">
+              <a:rPr lang="pt-BR" sz="1600" dirty="0">
                 <a:solidFill>
                   <a:schemeClr val="tx1"/>
                 </a:solidFill>
@@ -8480,7 +8496,7 @@
               <a:t>Instalar o </a:t>
             </a:r>
             <a:r>
-              <a:rPr lang="pt-BR" sz="2000" b="1" dirty="0">
+              <a:rPr lang="pt-BR" sz="1600" b="1" dirty="0">
                 <a:solidFill>
                   <a:schemeClr val="tx1"/>
                 </a:solidFill>
@@ -8490,7 +8506,7 @@
               <a:t>conector do MySQL</a:t>
             </a:r>
             <a:r>
-              <a:rPr lang="pt-BR" sz="2000" dirty="0">
+              <a:rPr lang="pt-BR" sz="1600" dirty="0">
                 <a:solidFill>
                   <a:schemeClr val="tx1"/>
                 </a:solidFill>
@@ -8500,7 +8516,7 @@
               <a:t> Python, </a:t>
             </a:r>
             <a:r>
-              <a:rPr lang="pt-BR" sz="2000" b="1" dirty="0" err="1">
+              <a:rPr lang="pt-BR" sz="1600" b="1" dirty="0" err="1">
                 <a:solidFill>
                   <a:srgbClr val="FF0000"/>
                 </a:solidFill>
@@ -8510,7 +8526,7 @@
               <a:t>mysql</a:t>
             </a:r>
             <a:r>
-              <a:rPr lang="pt-BR" sz="2000" b="1" dirty="0">
+              <a:rPr lang="pt-BR" sz="1600" b="1" dirty="0">
                 <a:solidFill>
                   <a:srgbClr val="FF0000"/>
                 </a:solidFill>
@@ -8520,7 +8536,7 @@
               <a:t>-conector-</a:t>
             </a:r>
             <a:r>
-              <a:rPr lang="pt-BR" sz="2000" b="1" dirty="0" err="1">
+              <a:rPr lang="pt-BR" sz="1600" b="1" dirty="0" err="1">
                 <a:solidFill>
                   <a:srgbClr val="FF0000"/>
                 </a:solidFill>
@@ -8529,7 +8545,7 @@
               </a:rPr>
               <a:t>python</a:t>
             </a:r>
-            <a:endParaRPr lang="pt-BR" sz="2000" dirty="0">
+            <a:endParaRPr lang="pt-BR" sz="1600" dirty="0">
               <a:solidFill>
                 <a:schemeClr val="tx1"/>
               </a:solidFill>
@@ -8542,35 +8558,35 @@
               <a:buAutoNum type="arabicPeriod"/>
             </a:pPr>
             <a:r>
-              <a:rPr lang="pt-BR" sz="2000" b="1" dirty="0" err="1">
+              <a:rPr lang="pt-BR" sz="1600" b="1" dirty="0" err="1">
                 <a:latin typeface="Times New Roman" panose="02020603050405020304" pitchFamily="18" charset="0"/>
                 <a:cs typeface="Times New Roman" panose="02020603050405020304" pitchFamily="18" charset="0"/>
               </a:rPr>
               <a:t>Cmd</a:t>
             </a:r>
             <a:r>
-              <a:rPr lang="pt-BR" sz="2000" b="1" dirty="0">
+              <a:rPr lang="pt-BR" sz="1600" b="1" dirty="0">
                 <a:latin typeface="Times New Roman" panose="02020603050405020304" pitchFamily="18" charset="0"/>
                 <a:cs typeface="Times New Roman" panose="02020603050405020304" pitchFamily="18" charset="0"/>
               </a:rPr>
               <a:t> Shell (</a:t>
             </a:r>
             <a:r>
-              <a:rPr lang="pt-BR" sz="2000" b="1" dirty="0" err="1">
+              <a:rPr lang="pt-BR" sz="1600" b="1" dirty="0" err="1">
                 <a:latin typeface="Times New Roman" panose="02020603050405020304" pitchFamily="18" charset="0"/>
                 <a:cs typeface="Times New Roman" panose="02020603050405020304" pitchFamily="18" charset="0"/>
               </a:rPr>
               <a:t>Atuailzar</a:t>
             </a:r>
             <a:r>
-              <a:rPr lang="pt-BR" sz="2000" b="1" dirty="0">
+              <a:rPr lang="pt-BR" sz="1600" b="1" dirty="0">
                 <a:latin typeface="Times New Roman" panose="02020603050405020304" pitchFamily="18" charset="0"/>
                 <a:cs typeface="Times New Roman" panose="02020603050405020304" pitchFamily="18" charset="0"/>
               </a:rPr>
               <a:t> versão do Python, </a:t>
             </a:r>
             <a:r>
-              <a:rPr lang="pt-BR" sz="2000" b="1" dirty="0">
+              <a:rPr lang="pt-BR" sz="1600" b="1" dirty="0">
                 <a:solidFill>
                   <a:srgbClr val="0070C0"/>
                 </a:solidFill>
@@ -8587,7 +8603,7 @@
               <a:t>www.python.org</a:t>
             </a:r>
             <a:r>
-              <a:rPr lang="pt-BR" sz="2000" b="1" dirty="0">
+              <a:rPr lang="pt-BR" sz="1600" b="1" dirty="0">
                 <a:latin typeface="Times New Roman" panose="02020603050405020304" pitchFamily="18" charset="0"/>
                 <a:cs typeface="Times New Roman" panose="02020603050405020304" pitchFamily="18" charset="0"/>
               </a:rPr>
@@ -8599,7 +8615,17 @@
               <a:buAutoNum type="arabicPeriod"/>
             </a:pPr>
             <a:r>
-              <a:rPr lang="pt-BR" sz="2000" b="1" dirty="0" err="1">
+              <a:rPr lang="pt-BR" sz="1600" b="1" dirty="0">
+                <a:solidFill>
+                  <a:srgbClr val="FF0000"/>
+                </a:solidFill>
+                <a:latin typeface="Times New Roman" panose="02020603050405020304" pitchFamily="18" charset="0"/>
+                <a:cs typeface="Times New Roman" panose="02020603050405020304" pitchFamily="18" charset="0"/>
+              </a:rPr>
+              <a:t>python.exe -m </a:t>
+            </a:r>
+            <a:r>
+              <a:rPr lang="pt-BR" sz="1600" b="1" dirty="0" err="1">
                 <a:solidFill>
                   <a:srgbClr val="0070C0"/>
                 </a:solidFill>
@@ -8609,7 +8635,7 @@
               <a:t>pip</a:t>
             </a:r>
             <a:r>
-              <a:rPr lang="pt-BR" sz="2000" b="1" dirty="0">
+              <a:rPr lang="pt-BR" sz="1600" b="1" dirty="0">
                 <a:solidFill>
                   <a:srgbClr val="0070C0"/>
                 </a:solidFill>
@@ -8619,7 +8645,7 @@
               <a:t> </a:t>
             </a:r>
             <a:r>
-              <a:rPr lang="pt-BR" sz="2000" b="1" dirty="0" err="1">
+              <a:rPr lang="pt-BR" sz="1600" b="1" dirty="0" err="1">
                 <a:solidFill>
                   <a:srgbClr val="0070C0"/>
                 </a:solidFill>
@@ -8629,14 +8655,14 @@
               <a:t>install</a:t>
             </a:r>
             <a:r>
-              <a:rPr lang="pt-BR" sz="2000" b="1" dirty="0">
+              <a:rPr lang="pt-BR" sz="1600" b="1" dirty="0">
                 <a:latin typeface="Times New Roman" panose="02020603050405020304" pitchFamily="18" charset="0"/>
                 <a:cs typeface="Times New Roman" panose="02020603050405020304" pitchFamily="18" charset="0"/>
               </a:rPr>
               <a:t> </a:t>
             </a:r>
             <a:r>
-              <a:rPr lang="pt-BR" sz="2000" b="1" dirty="0" err="1">
+              <a:rPr lang="pt-BR" sz="1600" b="1" dirty="0" err="1">
                 <a:solidFill>
                   <a:srgbClr val="FF0000"/>
                 </a:solidFill>
@@ -8646,7 +8672,7 @@
               <a:t>mysql</a:t>
             </a:r>
             <a:r>
-              <a:rPr lang="pt-BR" sz="2000" b="1" dirty="0">
+              <a:rPr lang="pt-BR" sz="1600" b="1" dirty="0">
                 <a:solidFill>
                   <a:srgbClr val="FF0000"/>
                 </a:solidFill>
@@ -8656,7 +8682,7 @@
               <a:t>-conector-</a:t>
             </a:r>
             <a:r>
-              <a:rPr lang="pt-BR" sz="2000" b="1" dirty="0" err="1">
+              <a:rPr lang="pt-BR" sz="1600" b="1" dirty="0" err="1">
                 <a:solidFill>
                   <a:srgbClr val="FF0000"/>
                 </a:solidFill>
@@ -8666,7 +8692,7 @@
               <a:t>python</a:t>
             </a:r>
             <a:r>
-              <a:rPr lang="pt-BR" sz="2000" b="1" dirty="0">
+              <a:rPr lang="pt-BR" sz="1600" b="1" dirty="0">
                 <a:solidFill>
                   <a:srgbClr val="FF0000"/>
                 </a:solidFill>
@@ -8676,353 +8702,453 @@
               <a:t>  (Windows; </a:t>
             </a:r>
             <a:r>
-              <a:rPr lang="pt-BR" sz="2000" b="1" dirty="0">
+              <a:rPr lang="pt-BR" sz="1600" b="1" dirty="0">
                 <a:latin typeface="Times New Roman" panose="02020603050405020304" pitchFamily="18" charset="0"/>
                 <a:cs typeface="Times New Roman" panose="02020603050405020304" pitchFamily="18" charset="0"/>
               </a:rPr>
               <a:t>pip3 Linux</a:t>
             </a:r>
             <a:r>
-              <a:rPr lang="pt-BR" sz="2000" b="1" dirty="0">
+              <a:rPr lang="pt-BR" sz="1600" b="1" dirty="0">
                 <a:solidFill>
                   <a:srgbClr val="FF0000"/>
                 </a:solidFill>
                 <a:latin typeface="Times New Roman" panose="02020603050405020304" pitchFamily="18" charset="0"/>
                 <a:cs typeface="Times New Roman" panose="02020603050405020304" pitchFamily="18" charset="0"/>
               </a:rPr>
-              <a:t>)	OU</a:t>
-            </a:r>
-          </a:p>
-          <a:p>
-            <a:pPr marL="457200" indent="-457200" algn="just">
-              <a:buAutoNum type="arabicPeriod"/>
-            </a:pPr>
-            <a:r>
-              <a:rPr lang="pt-BR" sz="2000" b="1" dirty="0">
-                <a:latin typeface="Times New Roman" panose="02020603050405020304" pitchFamily="18" charset="0"/>
-                <a:cs typeface="Times New Roman" panose="02020603050405020304" pitchFamily="18" charset="0"/>
-              </a:rPr>
-              <a:t>Instalar no </a:t>
-            </a:r>
-            <a:r>
-              <a:rPr lang="pt-BR" sz="2000" b="1" dirty="0" err="1">
-                <a:latin typeface="Times New Roman" panose="02020603050405020304" pitchFamily="18" charset="0"/>
-                <a:cs typeface="Times New Roman" panose="02020603050405020304" pitchFamily="18" charset="0"/>
-              </a:rPr>
-              <a:t>VSCode</a:t>
-            </a:r>
-            <a:endParaRPr lang="pt-BR" sz="2000" b="1" dirty="0">
-              <a:latin typeface="Times New Roman" panose="02020603050405020304" pitchFamily="18" charset="0"/>
-              <a:cs typeface="Times New Roman" panose="02020603050405020304" pitchFamily="18" charset="0"/>
-            </a:endParaRPr>
+              <a:t>)</a:t>
+            </a:r>
           </a:p>
           <a:p>
             <a:pPr marL="1076325" lvl="1" indent="-457200" algn="just">
               <a:buAutoNum type="arabicPeriod"/>
             </a:pPr>
             <a:r>
-              <a:rPr lang="pt-BR" sz="2000" b="1" dirty="0">
+              <a:rPr lang="pt-BR" sz="1600" b="1" dirty="0">
                 <a:solidFill>
                   <a:srgbClr val="FF0000"/>
                 </a:solidFill>
                 <a:latin typeface="Times New Roman" panose="02020603050405020304" pitchFamily="18" charset="0"/>
                 <a:cs typeface="Times New Roman" panose="02020603050405020304" pitchFamily="18" charset="0"/>
               </a:rPr>
-              <a:t>Extensão </a:t>
-            </a:r>
-            <a:r>
-              <a:rPr lang="pt-BR" sz="2000" b="1" dirty="0" err="1">
+              <a:t>python.exe -m </a:t>
+            </a:r>
+            <a:r>
+              <a:rPr lang="pt-BR" sz="1600" b="1" dirty="0" err="1">
                 <a:solidFill>
                   <a:srgbClr val="FF0000"/>
                 </a:solidFill>
                 <a:latin typeface="Times New Roman" panose="02020603050405020304" pitchFamily="18" charset="0"/>
                 <a:cs typeface="Times New Roman" panose="02020603050405020304" pitchFamily="18" charset="0"/>
               </a:rPr>
-              <a:t>SQLTolls</a:t>
-            </a:r>
-            <a:r>
-              <a:rPr lang="pt-BR" sz="2000" b="1" dirty="0">
+              <a:t>pip</a:t>
+            </a:r>
+            <a:r>
+              <a:rPr lang="pt-BR" sz="1600" b="1" dirty="0">
                 <a:solidFill>
                   <a:srgbClr val="FF0000"/>
                 </a:solidFill>
                 <a:latin typeface="Times New Roman" panose="02020603050405020304" pitchFamily="18" charset="0"/>
                 <a:cs typeface="Times New Roman" panose="02020603050405020304" pitchFamily="18" charset="0"/>
               </a:rPr>
-              <a:t>; Python </a:t>
-            </a:r>
-            <a:r>
-              <a:rPr lang="pt-BR" sz="2000" b="1" dirty="0" err="1">
+              <a:t> </a:t>
+            </a:r>
+            <a:r>
+              <a:rPr lang="pt-BR" sz="1600" b="1" dirty="0" err="1">
                 <a:solidFill>
                   <a:srgbClr val="FF0000"/>
                 </a:solidFill>
                 <a:latin typeface="Times New Roman" panose="02020603050405020304" pitchFamily="18" charset="0"/>
                 <a:cs typeface="Times New Roman" panose="02020603050405020304" pitchFamily="18" charset="0"/>
               </a:rPr>
-              <a:t>IntelliSense</a:t>
-            </a:r>
-            <a:r>
-              <a:rPr lang="pt-BR" sz="2000" b="1" dirty="0">
+              <a:t>install</a:t>
+            </a:r>
+            <a:r>
+              <a:rPr lang="pt-BR" sz="1600" b="1" dirty="0">
                 <a:solidFill>
                   <a:srgbClr val="FF0000"/>
                 </a:solidFill>
                 <a:latin typeface="Times New Roman" panose="02020603050405020304" pitchFamily="18" charset="0"/>
                 <a:cs typeface="Times New Roman" panose="02020603050405020304" pitchFamily="18" charset="0"/>
               </a:rPr>
-              <a:t>; </a:t>
-            </a:r>
-            <a:r>
-              <a:rPr lang="pt-BR" sz="2000" b="1" dirty="0" err="1">
-                <a:latin typeface="Times New Roman" panose="02020603050405020304" pitchFamily="18" charset="0"/>
-                <a:cs typeface="Times New Roman" panose="02020603050405020304" pitchFamily="18" charset="0"/>
-              </a:rPr>
-              <a:t>Theme</a:t>
-            </a:r>
-            <a:r>
-              <a:rPr lang="pt-BR" sz="2000" b="1" dirty="0">
+              <a:t> --upgrade </a:t>
+            </a:r>
+            <a:r>
+              <a:rPr lang="pt-BR" sz="1600" b="1" dirty="0" err="1">
                 <a:solidFill>
                   <a:srgbClr val="FF0000"/>
                 </a:solidFill>
                 <a:latin typeface="Times New Roman" panose="02020603050405020304" pitchFamily="18" charset="0"/>
                 <a:cs typeface="Times New Roman" panose="02020603050405020304" pitchFamily="18" charset="0"/>
               </a:rPr>
-              <a:t>: Dracula</a:t>
-            </a:r>
-          </a:p>
-          <a:p>
-            <a:pPr marL="1076325" lvl="1" indent="-457200" algn="just">
-              <a:buAutoNum type="arabicPeriod"/>
-            </a:pPr>
-            <a:r>
-              <a:rPr lang="pt-BR" sz="2000" b="1" dirty="0" err="1">
-                <a:solidFill>
-                  <a:srgbClr val="FF0000"/>
-                </a:solidFill>
-                <a:latin typeface="Times New Roman" panose="02020603050405020304" pitchFamily="18" charset="0"/>
-                <a:cs typeface="Times New Roman" panose="02020603050405020304" pitchFamily="18" charset="0"/>
-              </a:rPr>
-              <a:t>CTRL+Shift+P</a:t>
-            </a:r>
-            <a:r>
-              <a:rPr lang="pt-BR" sz="2000" b="1" dirty="0">
-                <a:solidFill>
-                  <a:srgbClr val="FF0000"/>
-                </a:solidFill>
-                <a:latin typeface="Times New Roman" panose="02020603050405020304" pitchFamily="18" charset="0"/>
-                <a:cs typeface="Times New Roman" panose="02020603050405020304" pitchFamily="18" charset="0"/>
-              </a:rPr>
-              <a:t> (</a:t>
-            </a:r>
-            <a:r>
-              <a:rPr lang="pt-BR" sz="2000" b="1" dirty="0" err="1">
-                <a:solidFill>
-                  <a:srgbClr val="FF0000"/>
-                </a:solidFill>
-                <a:latin typeface="Times New Roman" panose="02020603050405020304" pitchFamily="18" charset="0"/>
-                <a:cs typeface="Times New Roman" panose="02020603050405020304" pitchFamily="18" charset="0"/>
-              </a:rPr>
-              <a:t>Select</a:t>
-            </a:r>
-            <a:r>
-              <a:rPr lang="pt-BR" sz="2000" b="1" dirty="0">
-                <a:solidFill>
-                  <a:srgbClr val="FF0000"/>
-                </a:solidFill>
-                <a:latin typeface="Times New Roman" panose="02020603050405020304" pitchFamily="18" charset="0"/>
-                <a:cs typeface="Times New Roman" panose="02020603050405020304" pitchFamily="18" charset="0"/>
-              </a:rPr>
-              <a:t> </a:t>
-            </a:r>
-            <a:r>
-              <a:rPr lang="pt-BR" sz="2000" b="1" dirty="0" err="1">
-                <a:solidFill>
-                  <a:srgbClr val="FF0000"/>
-                </a:solidFill>
-                <a:latin typeface="Times New Roman" panose="02020603050405020304" pitchFamily="18" charset="0"/>
-                <a:cs typeface="Times New Roman" panose="02020603050405020304" pitchFamily="18" charset="0"/>
-              </a:rPr>
-              <a:t>Linter</a:t>
-            </a:r>
-            <a:r>
-              <a:rPr lang="pt-BR" sz="2000" b="1" dirty="0">
-                <a:solidFill>
-                  <a:srgbClr val="FF0000"/>
-                </a:solidFill>
-                <a:latin typeface="Times New Roman" panose="02020603050405020304" pitchFamily="18" charset="0"/>
-                <a:cs typeface="Times New Roman" panose="02020603050405020304" pitchFamily="18" charset="0"/>
-              </a:rPr>
-              <a:t> – instalar </a:t>
-            </a:r>
-            <a:r>
-              <a:rPr lang="pt-BR" sz="2000" b="1" dirty="0" err="1">
-                <a:solidFill>
-                  <a:srgbClr val="FF0000"/>
-                </a:solidFill>
-                <a:latin typeface="Times New Roman" panose="02020603050405020304" pitchFamily="18" charset="0"/>
-                <a:cs typeface="Times New Roman" panose="02020603050405020304" pitchFamily="18" charset="0"/>
-              </a:rPr>
-              <a:t>pylint</a:t>
-            </a:r>
-            <a:r>
-              <a:rPr lang="pt-BR" sz="2000" b="1" dirty="0">
-                <a:solidFill>
-                  <a:srgbClr val="FF0000"/>
-                </a:solidFill>
-                <a:latin typeface="Times New Roman" panose="02020603050405020304" pitchFamily="18" charset="0"/>
-                <a:cs typeface="Times New Roman" panose="02020603050405020304" pitchFamily="18" charset="0"/>
-              </a:rPr>
-              <a:t> – </a:t>
-            </a:r>
-            <a:r>
-              <a:rPr lang="pt-BR" sz="2000" b="1" dirty="0">
-                <a:latin typeface="Times New Roman" panose="02020603050405020304" pitchFamily="18" charset="0"/>
-                <a:cs typeface="Times New Roman" panose="02020603050405020304" pitchFamily="18" charset="0"/>
-              </a:rPr>
-              <a:t>formatador de </a:t>
-            </a:r>
-            <a:r>
-              <a:rPr lang="pt-BR" sz="2000" b="1" dirty="0" err="1">
-                <a:latin typeface="Times New Roman" panose="02020603050405020304" pitchFamily="18" charset="0"/>
-                <a:cs typeface="Times New Roman" panose="02020603050405020304" pitchFamily="18" charset="0"/>
-              </a:rPr>
-              <a:t>code</a:t>
-            </a:r>
-            <a:r>
-              <a:rPr lang="pt-BR" sz="2000" b="1" dirty="0">
-                <a:solidFill>
-                  <a:srgbClr val="FF0000"/>
-                </a:solidFill>
-                <a:latin typeface="Times New Roman" panose="02020603050405020304" pitchFamily="18" charset="0"/>
-                <a:cs typeface="Times New Roman" panose="02020603050405020304" pitchFamily="18" charset="0"/>
-              </a:rPr>
-              <a:t>)</a:t>
-            </a:r>
-          </a:p>
-          <a:p>
-            <a:pPr marL="1076325" lvl="1" indent="-457200" algn="just">
-              <a:buAutoNum type="arabicPeriod"/>
-            </a:pPr>
-            <a:r>
-              <a:rPr lang="pt-BR" sz="2000" b="1" dirty="0">
-                <a:solidFill>
-                  <a:srgbClr val="FF0000"/>
-                </a:solidFill>
-                <a:latin typeface="Times New Roman" panose="02020603050405020304" pitchFamily="18" charset="0"/>
-                <a:cs typeface="Times New Roman" panose="02020603050405020304" pitchFamily="18" charset="0"/>
-              </a:rPr>
-              <a:t>No arquivo </a:t>
-            </a:r>
-            <a:r>
-              <a:rPr lang="pt-BR" sz="2000" b="1" dirty="0" err="1">
-                <a:solidFill>
-                  <a:srgbClr val="FF0000"/>
-                </a:solidFill>
-                <a:latin typeface="Times New Roman" panose="02020603050405020304" pitchFamily="18" charset="0"/>
-                <a:cs typeface="Times New Roman" panose="02020603050405020304" pitchFamily="18" charset="0"/>
-              </a:rPr>
-              <a:t>settings.json</a:t>
-            </a:r>
-            <a:r>
-              <a:rPr lang="pt-BR" sz="2000" b="1" dirty="0">
-                <a:solidFill>
-                  <a:srgbClr val="FF0000"/>
-                </a:solidFill>
-                <a:latin typeface="Times New Roman" panose="02020603050405020304" pitchFamily="18" charset="0"/>
-                <a:cs typeface="Times New Roman" panose="02020603050405020304" pitchFamily="18" charset="0"/>
-              </a:rPr>
-              <a:t> (Incluir)</a:t>
-            </a:r>
-          </a:p>
-          <a:p>
-            <a:pPr marL="1520190" lvl="2" indent="-457200" algn="just">
-              <a:buAutoNum type="arabicPeriod"/>
-            </a:pPr>
-            <a:r>
-              <a:rPr lang="pt-BR" sz="2000" b="1" dirty="0">
-                <a:solidFill>
-                  <a:srgbClr val="FF0000"/>
-                </a:solidFill>
-                <a:latin typeface="Times New Roman" panose="02020603050405020304" pitchFamily="18" charset="0"/>
-                <a:cs typeface="Times New Roman" panose="02020603050405020304" pitchFamily="18" charset="0"/>
-              </a:rPr>
-              <a:t>,</a:t>
-            </a:r>
-            <a:r>
-              <a:rPr lang="pt-BR" sz="2000" b="1" dirty="0">
-                <a:solidFill>
-                  <a:schemeClr val="tx1"/>
-                </a:solidFill>
-                <a:latin typeface="Times New Roman" panose="02020603050405020304" pitchFamily="18" charset="0"/>
-                <a:cs typeface="Times New Roman" panose="02020603050405020304" pitchFamily="18" charset="0"/>
-              </a:rPr>
-              <a:t> "</a:t>
-            </a:r>
-            <a:r>
-              <a:rPr lang="pt-BR" sz="2000" b="1" dirty="0" err="1">
-                <a:solidFill>
-                  <a:schemeClr val="tx1"/>
-                </a:solidFill>
-                <a:latin typeface="Times New Roman" panose="02020603050405020304" pitchFamily="18" charset="0"/>
-                <a:cs typeface="Times New Roman" panose="02020603050405020304" pitchFamily="18" charset="0"/>
-              </a:rPr>
-              <a:t>python.pythonPath</a:t>
-            </a:r>
-            <a:r>
-              <a:rPr lang="pt-BR" sz="2000" b="1" dirty="0">
-                <a:solidFill>
-                  <a:schemeClr val="tx1"/>
-                </a:solidFill>
-                <a:latin typeface="Times New Roman" panose="02020603050405020304" pitchFamily="18" charset="0"/>
-                <a:cs typeface="Times New Roman" panose="02020603050405020304" pitchFamily="18" charset="0"/>
-              </a:rPr>
-              <a:t>": "C:\\Program Files (x86)\\Microsoft Visual Studio\\</a:t>
-            </a:r>
-            <a:r>
-              <a:rPr lang="pt-BR" sz="2000" b="1" dirty="0" err="1">
-                <a:solidFill>
-                  <a:schemeClr val="tx1"/>
-                </a:solidFill>
-                <a:latin typeface="Times New Roman" panose="02020603050405020304" pitchFamily="18" charset="0"/>
-                <a:cs typeface="Times New Roman" panose="02020603050405020304" pitchFamily="18" charset="0"/>
-              </a:rPr>
-              <a:t>Shared</a:t>
-            </a:r>
-            <a:r>
-              <a:rPr lang="pt-BR" sz="2000" b="1">
-                <a:solidFill>
-                  <a:schemeClr val="tx1"/>
-                </a:solidFill>
-                <a:latin typeface="Times New Roman" panose="02020603050405020304" pitchFamily="18" charset="0"/>
-                <a:cs typeface="Times New Roman" panose="02020603050405020304" pitchFamily="18" charset="0"/>
-              </a:rPr>
-              <a:t>\\</a:t>
-            </a:r>
-            <a:r>
-              <a:rPr lang="pt-BR" sz="2000" b="1">
-                <a:solidFill>
-                  <a:srgbClr val="FF0000"/>
-                </a:solidFill>
-                <a:latin typeface="Times New Roman" panose="02020603050405020304" pitchFamily="18" charset="0"/>
-                <a:cs typeface="Times New Roman" panose="02020603050405020304" pitchFamily="18" charset="0"/>
-              </a:rPr>
-              <a:t>Python39_64</a:t>
-            </a:r>
-            <a:r>
-              <a:rPr lang="pt-BR" sz="2000" b="1">
-                <a:solidFill>
-                  <a:schemeClr val="tx1"/>
-                </a:solidFill>
-                <a:latin typeface="Times New Roman" panose="02020603050405020304" pitchFamily="18" charset="0"/>
-                <a:cs typeface="Times New Roman" panose="02020603050405020304" pitchFamily="18" charset="0"/>
-              </a:rPr>
-              <a:t>\\python.exe"</a:t>
-            </a:r>
-            <a:endParaRPr lang="pt-BR" sz="2000" b="1" dirty="0">
+              <a:t>mysql-connector-python</a:t>
+            </a:r>
+            <a:endParaRPr lang="pt-BR" sz="1600" b="1" dirty="0">
               <a:solidFill>
-                <a:schemeClr val="tx1"/>
+                <a:srgbClr val="FF0000"/>
               </a:solidFill>
               <a:latin typeface="Times New Roman" panose="02020603050405020304" pitchFamily="18" charset="0"/>
               <a:cs typeface="Times New Roman" panose="02020603050405020304" pitchFamily="18" charset="0"/>
             </a:endParaRPr>
+          </a:p>
+          <a:p>
+            <a:pPr marL="1076325" lvl="1" indent="-457200" algn="just">
+              <a:buAutoNum type="arabicPeriod"/>
+            </a:pPr>
+            <a:r>
+              <a:rPr lang="en-US" sz="1600" b="1" dirty="0">
+                <a:solidFill>
+                  <a:srgbClr val="FF0000"/>
+                </a:solidFill>
+                <a:latin typeface="Times New Roman" panose="02020603050405020304" pitchFamily="18" charset="0"/>
+                <a:cs typeface="Times New Roman" panose="02020603050405020304" pitchFamily="18" charset="0"/>
+              </a:rPr>
+              <a:t>python.exe -m pip show </a:t>
+            </a:r>
+            <a:r>
+              <a:rPr lang="en-US" sz="1600" b="1" dirty="0" err="1">
+                <a:solidFill>
+                  <a:srgbClr val="FF0000"/>
+                </a:solidFill>
+                <a:latin typeface="Times New Roman" panose="02020603050405020304" pitchFamily="18" charset="0"/>
+                <a:cs typeface="Times New Roman" panose="02020603050405020304" pitchFamily="18" charset="0"/>
+              </a:rPr>
+              <a:t>mysql</a:t>
+            </a:r>
+            <a:r>
+              <a:rPr lang="en-US" sz="1600" b="1" dirty="0">
+                <a:solidFill>
+                  <a:srgbClr val="FF0000"/>
+                </a:solidFill>
+                <a:latin typeface="Times New Roman" panose="02020603050405020304" pitchFamily="18" charset="0"/>
+                <a:cs typeface="Times New Roman" panose="02020603050405020304" pitchFamily="18" charset="0"/>
+              </a:rPr>
+              <a:t>-connector-python</a:t>
+            </a:r>
+          </a:p>
+          <a:p>
+            <a:pPr marL="457200" indent="-457200" algn="just">
+              <a:buAutoNum type="arabicPeriod"/>
+            </a:pPr>
+            <a:r>
+              <a:rPr lang="pt-BR" sz="1600" b="1" dirty="0">
+                <a:latin typeface="Times New Roman" panose="02020603050405020304" pitchFamily="18" charset="0"/>
+                <a:cs typeface="Times New Roman" panose="02020603050405020304" pitchFamily="18" charset="0"/>
+              </a:rPr>
+              <a:t>Instalar no </a:t>
+            </a:r>
+            <a:r>
+              <a:rPr lang="pt-BR" sz="1600" b="1" dirty="0" err="1">
+                <a:latin typeface="Times New Roman" panose="02020603050405020304" pitchFamily="18" charset="0"/>
+                <a:cs typeface="Times New Roman" panose="02020603050405020304" pitchFamily="18" charset="0"/>
+              </a:rPr>
+              <a:t>VSCode</a:t>
+            </a:r>
+            <a:endParaRPr lang="pt-BR" sz="1600" b="1" dirty="0">
+              <a:latin typeface="Times New Roman" panose="02020603050405020304" pitchFamily="18" charset="0"/>
+              <a:cs typeface="Times New Roman" panose="02020603050405020304" pitchFamily="18" charset="0"/>
+            </a:endParaRPr>
+          </a:p>
+          <a:p>
+            <a:pPr marL="1076325" lvl="1" indent="-457200" algn="just">
+              <a:buAutoNum type="arabicPeriod"/>
+            </a:pPr>
+            <a:r>
+              <a:rPr lang="pt-BR" sz="1600" b="1" dirty="0">
+                <a:solidFill>
+                  <a:srgbClr val="FF0000"/>
+                </a:solidFill>
+                <a:latin typeface="Times New Roman" panose="02020603050405020304" pitchFamily="18" charset="0"/>
+                <a:cs typeface="Times New Roman" panose="02020603050405020304" pitchFamily="18" charset="0"/>
+              </a:rPr>
+              <a:t>Extensão </a:t>
+            </a:r>
+            <a:r>
+              <a:rPr lang="pt-BR" sz="1600" b="1" dirty="0" err="1">
+                <a:solidFill>
+                  <a:srgbClr val="FF0000"/>
+                </a:solidFill>
+                <a:latin typeface="Times New Roman" panose="02020603050405020304" pitchFamily="18" charset="0"/>
+                <a:cs typeface="Times New Roman" panose="02020603050405020304" pitchFamily="18" charset="0"/>
+              </a:rPr>
+              <a:t>SQLTolls</a:t>
+            </a:r>
+            <a:r>
+              <a:rPr lang="pt-BR" sz="1600" b="1" dirty="0">
+                <a:solidFill>
+                  <a:srgbClr val="FF0000"/>
+                </a:solidFill>
+                <a:latin typeface="Times New Roman" panose="02020603050405020304" pitchFamily="18" charset="0"/>
+                <a:cs typeface="Times New Roman" panose="02020603050405020304" pitchFamily="18" charset="0"/>
+              </a:rPr>
+              <a:t>; Python </a:t>
+            </a:r>
+            <a:r>
+              <a:rPr lang="pt-BR" sz="1600" b="1" dirty="0" err="1">
+                <a:solidFill>
+                  <a:srgbClr val="FF0000"/>
+                </a:solidFill>
+                <a:latin typeface="Times New Roman" panose="02020603050405020304" pitchFamily="18" charset="0"/>
+                <a:cs typeface="Times New Roman" panose="02020603050405020304" pitchFamily="18" charset="0"/>
+              </a:rPr>
+              <a:t>IntelliSense</a:t>
+            </a:r>
+            <a:r>
+              <a:rPr lang="pt-BR" sz="1600" b="1" dirty="0">
+                <a:solidFill>
+                  <a:srgbClr val="FF0000"/>
+                </a:solidFill>
+                <a:latin typeface="Times New Roman" panose="02020603050405020304" pitchFamily="18" charset="0"/>
+                <a:cs typeface="Times New Roman" panose="02020603050405020304" pitchFamily="18" charset="0"/>
+              </a:rPr>
+              <a:t>; </a:t>
+            </a:r>
+            <a:r>
+              <a:rPr lang="pt-BR" sz="1600" b="1" dirty="0" err="1">
+                <a:latin typeface="Times New Roman" panose="02020603050405020304" pitchFamily="18" charset="0"/>
+                <a:cs typeface="Times New Roman" panose="02020603050405020304" pitchFamily="18" charset="0"/>
+              </a:rPr>
+              <a:t>Theme</a:t>
+            </a:r>
+            <a:r>
+              <a:rPr lang="pt-BR" sz="1600" b="1" dirty="0">
+                <a:solidFill>
+                  <a:srgbClr val="FF0000"/>
+                </a:solidFill>
+                <a:latin typeface="Times New Roman" panose="02020603050405020304" pitchFamily="18" charset="0"/>
+                <a:cs typeface="Times New Roman" panose="02020603050405020304" pitchFamily="18" charset="0"/>
+              </a:rPr>
+              <a:t>: Dracula</a:t>
+            </a:r>
+          </a:p>
+          <a:p>
+            <a:pPr marL="1076325" lvl="1" indent="-457200" algn="just">
+              <a:buAutoNum type="arabicPeriod"/>
+            </a:pPr>
+            <a:r>
+              <a:rPr lang="pt-BR" sz="1600" b="1" dirty="0" err="1">
+                <a:solidFill>
+                  <a:srgbClr val="FF0000"/>
+                </a:solidFill>
+                <a:latin typeface="Times New Roman" panose="02020603050405020304" pitchFamily="18" charset="0"/>
+                <a:cs typeface="Times New Roman" panose="02020603050405020304" pitchFamily="18" charset="0"/>
+              </a:rPr>
+              <a:t>CTRL+Shift+P</a:t>
+            </a:r>
+            <a:r>
+              <a:rPr lang="pt-BR" sz="1600" b="1" dirty="0">
+                <a:solidFill>
+                  <a:srgbClr val="FF0000"/>
+                </a:solidFill>
+                <a:latin typeface="Times New Roman" panose="02020603050405020304" pitchFamily="18" charset="0"/>
+                <a:cs typeface="Times New Roman" panose="02020603050405020304" pitchFamily="18" charset="0"/>
+              </a:rPr>
+              <a:t> (</a:t>
+            </a:r>
+            <a:r>
+              <a:rPr lang="pt-BR" sz="1600" b="1" dirty="0" err="1">
+                <a:solidFill>
+                  <a:srgbClr val="FF0000"/>
+                </a:solidFill>
+                <a:latin typeface="Times New Roman" panose="02020603050405020304" pitchFamily="18" charset="0"/>
+                <a:cs typeface="Times New Roman" panose="02020603050405020304" pitchFamily="18" charset="0"/>
+              </a:rPr>
+              <a:t>Select</a:t>
+            </a:r>
+            <a:r>
+              <a:rPr lang="pt-BR" sz="1600" b="1" dirty="0">
+                <a:solidFill>
+                  <a:srgbClr val="FF0000"/>
+                </a:solidFill>
+                <a:latin typeface="Times New Roman" panose="02020603050405020304" pitchFamily="18" charset="0"/>
+                <a:cs typeface="Times New Roman" panose="02020603050405020304" pitchFamily="18" charset="0"/>
+              </a:rPr>
+              <a:t> </a:t>
+            </a:r>
+            <a:r>
+              <a:rPr lang="pt-BR" sz="1600" b="1" dirty="0" err="1">
+                <a:solidFill>
+                  <a:srgbClr val="FF0000"/>
+                </a:solidFill>
+                <a:latin typeface="Times New Roman" panose="02020603050405020304" pitchFamily="18" charset="0"/>
+                <a:cs typeface="Times New Roman" panose="02020603050405020304" pitchFamily="18" charset="0"/>
+              </a:rPr>
+              <a:t>Linter</a:t>
+            </a:r>
+            <a:r>
+              <a:rPr lang="pt-BR" sz="1600" b="1" dirty="0">
+                <a:solidFill>
+                  <a:srgbClr val="FF0000"/>
+                </a:solidFill>
+                <a:latin typeface="Times New Roman" panose="02020603050405020304" pitchFamily="18" charset="0"/>
+                <a:cs typeface="Times New Roman" panose="02020603050405020304" pitchFamily="18" charset="0"/>
+              </a:rPr>
+              <a:t> – instalar </a:t>
+            </a:r>
+            <a:r>
+              <a:rPr lang="pt-BR" sz="1600" b="1" dirty="0" err="1">
+                <a:solidFill>
+                  <a:srgbClr val="FF0000"/>
+                </a:solidFill>
+                <a:latin typeface="Times New Roman" panose="02020603050405020304" pitchFamily="18" charset="0"/>
+                <a:cs typeface="Times New Roman" panose="02020603050405020304" pitchFamily="18" charset="0"/>
+              </a:rPr>
+              <a:t>pylint</a:t>
+            </a:r>
+            <a:r>
+              <a:rPr lang="pt-BR" sz="1600" b="1" dirty="0">
+                <a:solidFill>
+                  <a:srgbClr val="FF0000"/>
+                </a:solidFill>
+                <a:latin typeface="Times New Roman" panose="02020603050405020304" pitchFamily="18" charset="0"/>
+                <a:cs typeface="Times New Roman" panose="02020603050405020304" pitchFamily="18" charset="0"/>
+              </a:rPr>
+              <a:t> – </a:t>
+            </a:r>
+            <a:r>
+              <a:rPr lang="pt-BR" sz="1600" b="1" dirty="0">
+                <a:latin typeface="Times New Roman" panose="02020603050405020304" pitchFamily="18" charset="0"/>
+                <a:cs typeface="Times New Roman" panose="02020603050405020304" pitchFamily="18" charset="0"/>
+              </a:rPr>
+              <a:t>formatador de </a:t>
+            </a:r>
+            <a:r>
+              <a:rPr lang="pt-BR" sz="1600" b="1" dirty="0" err="1">
+                <a:latin typeface="Times New Roman" panose="02020603050405020304" pitchFamily="18" charset="0"/>
+                <a:cs typeface="Times New Roman" panose="02020603050405020304" pitchFamily="18" charset="0"/>
+              </a:rPr>
+              <a:t>code</a:t>
+            </a:r>
+            <a:r>
+              <a:rPr lang="pt-BR" sz="1600" b="1" dirty="0">
+                <a:solidFill>
+                  <a:srgbClr val="FF0000"/>
+                </a:solidFill>
+                <a:latin typeface="Times New Roman" panose="02020603050405020304" pitchFamily="18" charset="0"/>
+                <a:cs typeface="Times New Roman" panose="02020603050405020304" pitchFamily="18" charset="0"/>
+              </a:rPr>
+              <a:t>)</a:t>
+            </a:r>
+          </a:p>
+          <a:p>
+            <a:pPr marL="1076325" lvl="1" indent="-457200" algn="just">
+              <a:buAutoNum type="arabicPeriod"/>
+            </a:pPr>
+            <a:r>
+              <a:rPr lang="pt-BR" sz="1600" b="1" dirty="0">
+                <a:solidFill>
+                  <a:srgbClr val="FF0000"/>
+                </a:solidFill>
+                <a:latin typeface="Times New Roman" panose="02020603050405020304" pitchFamily="18" charset="0"/>
+                <a:cs typeface="Times New Roman" panose="02020603050405020304" pitchFamily="18" charset="0"/>
+              </a:rPr>
+              <a:t>No arquivo </a:t>
+            </a:r>
+            <a:r>
+              <a:rPr lang="pt-BR" sz="1600" b="1" dirty="0" err="1">
+                <a:solidFill>
+                  <a:srgbClr val="FF0000"/>
+                </a:solidFill>
+                <a:latin typeface="Times New Roman" panose="02020603050405020304" pitchFamily="18" charset="0"/>
+                <a:cs typeface="Times New Roman" panose="02020603050405020304" pitchFamily="18" charset="0"/>
+              </a:rPr>
+              <a:t>settings.json</a:t>
+            </a:r>
+            <a:r>
+              <a:rPr lang="pt-BR" sz="1600" b="1" dirty="0">
+                <a:solidFill>
+                  <a:srgbClr val="FF0000"/>
+                </a:solidFill>
+                <a:latin typeface="Times New Roman" panose="02020603050405020304" pitchFamily="18" charset="0"/>
+                <a:cs typeface="Times New Roman" panose="02020603050405020304" pitchFamily="18" charset="0"/>
+              </a:rPr>
+              <a:t> (Incluir)</a:t>
+            </a:r>
+          </a:p>
+          <a:p>
+            <a:pPr marL="1520190" lvl="2" indent="-457200" algn="just">
+              <a:buAutoNum type="arabicPeriod"/>
+            </a:pPr>
+            <a:r>
+              <a:rPr lang="pt-BR" sz="1600" b="1" dirty="0">
+                <a:solidFill>
+                  <a:srgbClr val="FF0000"/>
+                </a:solidFill>
+                <a:latin typeface="Times New Roman" panose="02020603050405020304" pitchFamily="18" charset="0"/>
+                <a:cs typeface="Times New Roman" panose="02020603050405020304" pitchFamily="18" charset="0"/>
+              </a:rPr>
+              <a:t>,</a:t>
+            </a:r>
+            <a:r>
+              <a:rPr lang="pt-BR" sz="1600" b="1" dirty="0">
+                <a:solidFill>
+                  <a:schemeClr val="tx1"/>
+                </a:solidFill>
+                <a:latin typeface="Times New Roman" panose="02020603050405020304" pitchFamily="18" charset="0"/>
+                <a:cs typeface="Times New Roman" panose="02020603050405020304" pitchFamily="18" charset="0"/>
+              </a:rPr>
+              <a:t> "</a:t>
+            </a:r>
+            <a:r>
+              <a:rPr lang="pt-BR" sz="1600" b="1" dirty="0" err="1">
+                <a:solidFill>
+                  <a:schemeClr val="tx1"/>
+                </a:solidFill>
+                <a:latin typeface="Times New Roman" panose="02020603050405020304" pitchFamily="18" charset="0"/>
+                <a:cs typeface="Times New Roman" panose="02020603050405020304" pitchFamily="18" charset="0"/>
+              </a:rPr>
+              <a:t>python.pythonPath</a:t>
+            </a:r>
+            <a:r>
+              <a:rPr lang="pt-BR" sz="1600" b="1" dirty="0">
+                <a:solidFill>
+                  <a:schemeClr val="tx1"/>
+                </a:solidFill>
+                <a:latin typeface="Times New Roman" panose="02020603050405020304" pitchFamily="18" charset="0"/>
+                <a:cs typeface="Times New Roman" panose="02020603050405020304" pitchFamily="18" charset="0"/>
+              </a:rPr>
+              <a:t>": "C:\\Program Files (x86)\\Microsoft Visual Studio\\</a:t>
+            </a:r>
+            <a:r>
+              <a:rPr lang="pt-BR" sz="1600" b="1" dirty="0" err="1">
+                <a:solidFill>
+                  <a:schemeClr val="tx1"/>
+                </a:solidFill>
+                <a:latin typeface="Times New Roman" panose="02020603050405020304" pitchFamily="18" charset="0"/>
+                <a:cs typeface="Times New Roman" panose="02020603050405020304" pitchFamily="18" charset="0"/>
+              </a:rPr>
+              <a:t>Shared</a:t>
+            </a:r>
+            <a:r>
+              <a:rPr lang="pt-BR" sz="1600" b="1" dirty="0">
+                <a:solidFill>
+                  <a:schemeClr val="tx1"/>
+                </a:solidFill>
+                <a:latin typeface="Times New Roman" panose="02020603050405020304" pitchFamily="18" charset="0"/>
+                <a:cs typeface="Times New Roman" panose="02020603050405020304" pitchFamily="18" charset="0"/>
+              </a:rPr>
+              <a:t>\\</a:t>
+            </a:r>
+            <a:r>
+              <a:rPr lang="pt-BR" sz="1600" b="1" dirty="0">
+                <a:solidFill>
+                  <a:srgbClr val="FF0000"/>
+                </a:solidFill>
+                <a:latin typeface="Times New Roman" panose="02020603050405020304" pitchFamily="18" charset="0"/>
+                <a:cs typeface="Times New Roman" panose="02020603050405020304" pitchFamily="18" charset="0"/>
+              </a:rPr>
+              <a:t>Python39_64</a:t>
+            </a:r>
+            <a:r>
+              <a:rPr lang="pt-BR" sz="1600" b="1" dirty="0">
+                <a:solidFill>
+                  <a:schemeClr val="tx1"/>
+                </a:solidFill>
+                <a:latin typeface="Times New Roman" panose="02020603050405020304" pitchFamily="18" charset="0"/>
+                <a:cs typeface="Times New Roman" panose="02020603050405020304" pitchFamily="18" charset="0"/>
+              </a:rPr>
+              <a:t>\\python.exe"</a:t>
+            </a:r>
           </a:p>
         </p:txBody>
       </p:sp>
@@ -9321,17 +9447,17 @@
                 <a:latin typeface="Times New Roman" panose="02020603050405020304" pitchFamily="18" charset="0"/>
                 <a:cs typeface="Times New Roman" panose="02020603050405020304" pitchFamily="18" charset="0"/>
               </a:rPr>
-              <a:t>="</a:t>
-            </a:r>
-            <a:r>
-              <a:rPr lang="pt-BR" sz="2400" dirty="0" err="1">
-                <a:solidFill>
-                  <a:schemeClr val="tx1"/>
-                </a:solidFill>
-                <a:latin typeface="Times New Roman" panose="02020603050405020304" pitchFamily="18" charset="0"/>
-                <a:cs typeface="Times New Roman" panose="02020603050405020304" pitchFamily="18" charset="0"/>
-              </a:rPr>
-              <a:t>coursejdbc</a:t>
+              <a:t>=“banco", </a:t>
+            </a:r>
+            <a:r>
+              <a:rPr lang="pt-BR" sz="2400" b="1" dirty="0" err="1">
+                <a:solidFill>
+                  <a:schemeClr val="tx1"/>
+                </a:solidFill>
+                <a:latin typeface="Times New Roman" panose="02020603050405020304" pitchFamily="18" charset="0"/>
+                <a:cs typeface="Times New Roman" panose="02020603050405020304" pitchFamily="18" charset="0"/>
+              </a:rPr>
+              <a:t>user</a:t>
             </a:r>
             <a:r>
               <a:rPr lang="pt-BR" sz="2400" dirty="0">
@@ -9341,37 +9467,14 @@
                 <a:latin typeface="Times New Roman" panose="02020603050405020304" pitchFamily="18" charset="0"/>
                 <a:cs typeface="Times New Roman" panose="02020603050405020304" pitchFamily="18" charset="0"/>
               </a:rPr>
-              <a:t>", </a:t>
-            </a:r>
-            <a:r>
-              <a:rPr lang="pt-BR" sz="2400" b="1" dirty="0" err="1">
-                <a:solidFill>
-                  <a:schemeClr val="tx1"/>
-                </a:solidFill>
-                <a:latin typeface="Times New Roman" panose="02020603050405020304" pitchFamily="18" charset="0"/>
-                <a:cs typeface="Times New Roman" panose="02020603050405020304" pitchFamily="18" charset="0"/>
-              </a:rPr>
-              <a:t>user</a:t>
+              <a:t>=</a:t>
             </a:r>
             <a:r>
               <a:rPr lang="pt-BR" sz="2400" dirty="0">
-                <a:solidFill>
-                  <a:schemeClr val="tx1"/>
-                </a:solidFill>
-                <a:latin typeface="Times New Roman" panose="02020603050405020304" pitchFamily="18" charset="0"/>
-                <a:cs typeface="Times New Roman" panose="02020603050405020304" pitchFamily="18" charset="0"/>
-              </a:rPr>
-              <a:t>="</a:t>
-            </a:r>
-            <a:r>
-              <a:rPr lang="pt-BR" sz="2400" dirty="0" err="1">
-                <a:solidFill>
-                  <a:schemeClr val="tx1"/>
-                </a:solidFill>
-                <a:latin typeface="Times New Roman" panose="02020603050405020304" pitchFamily="18" charset="0"/>
-                <a:cs typeface="Times New Roman" panose="02020603050405020304" pitchFamily="18" charset="0"/>
-              </a:rPr>
-              <a:t>developer</a:t>
+                <a:latin typeface="Times New Roman" panose="02020603050405020304" pitchFamily="18" charset="0"/>
+                <a:cs typeface="Times New Roman" panose="02020603050405020304" pitchFamily="18" charset="0"/>
+              </a:rPr>
+              <a:t>"root</a:t>
             </a:r>
             <a:r>
               <a:rPr lang="pt-BR" sz="2400" dirty="0">
@@ -10182,27 +10285,24 @@
                 <a:latin typeface="Times New Roman" panose="02020603050405020304" pitchFamily="18" charset="0"/>
                 <a:cs typeface="Times New Roman" panose="02020603050405020304" pitchFamily="18" charset="0"/>
               </a:rPr>
-              <a:t> = </a:t>
-            </a:r>
-            <a:r>
-              <a:rPr lang="pt-BR" sz="2400" b="1" dirty="0">
-                <a:solidFill>
-                  <a:srgbClr val="FF0000"/>
-                </a:solidFill>
-                <a:latin typeface="Times New Roman" panose="02020603050405020304" pitchFamily="18" charset="0"/>
-                <a:cs typeface="Times New Roman" panose="02020603050405020304" pitchFamily="18" charset="0"/>
-              </a:rPr>
-              <a:t>f</a:t>
-            </a:r>
-            <a:r>
-              <a:rPr lang="pt-BR" sz="2400" dirty="0">
-                <a:solidFill>
-                  <a:schemeClr val="tx1"/>
-                </a:solidFill>
-                <a:latin typeface="Times New Roman" panose="02020603050405020304" pitchFamily="18" charset="0"/>
-                <a:cs typeface="Times New Roman" panose="02020603050405020304" pitchFamily="18" charset="0"/>
-              </a:rPr>
-              <a:t> "</a:t>
+              <a:t> </a:t>
+            </a:r>
+            <a:r>
+              <a:rPr lang="pt-BR" sz="2400">
+                <a:latin typeface="Times New Roman" panose="02020603050405020304" pitchFamily="18" charset="0"/>
+                <a:cs typeface="Times New Roman" panose="02020603050405020304" pitchFamily="18" charset="0"/>
+              </a:rPr>
+              <a:t>= </a:t>
+            </a:r>
+            <a:r>
+              <a:rPr lang="pt-BR" sz="2400">
+                <a:solidFill>
+                  <a:schemeClr val="tx1"/>
+                </a:solidFill>
+                <a:latin typeface="Times New Roman" panose="02020603050405020304" pitchFamily="18" charset="0"/>
+                <a:cs typeface="Times New Roman" panose="02020603050405020304" pitchFamily="18" charset="0"/>
+              </a:rPr>
+              <a:t>"</a:t>
             </a:r>
             <a:r>
               <a:rPr lang="pt-BR" sz="2400" b="1" dirty="0" err="1">
@@ -10520,7 +10620,7 @@
                 <a:latin typeface="Times New Roman" panose="02020603050405020304" pitchFamily="18" charset="0"/>
                 <a:cs typeface="Times New Roman" panose="02020603050405020304" pitchFamily="18" charset="0"/>
               </a:rPr>
-              <a:t>(“Digite o nome:”)</a:t>
+              <a:t>("Digite o nome:")</a:t>
             </a:r>
             <a:endParaRPr lang="pt-BR" sz="2400" dirty="0">
               <a:solidFill>
@@ -10549,127 +10649,99 @@
               <a:t> = </a:t>
             </a:r>
             <a:r>
+              <a:rPr lang="pt-BR" sz="2400" dirty="0">
+                <a:solidFill>
+                  <a:schemeClr val="tx1"/>
+                </a:solidFill>
+                <a:latin typeface="Times New Roman" panose="02020603050405020304" pitchFamily="18" charset="0"/>
+                <a:cs typeface="Times New Roman" panose="02020603050405020304" pitchFamily="18" charset="0"/>
+              </a:rPr>
+              <a:t>"</a:t>
+            </a:r>
+            <a:r>
               <a:rPr lang="pt-BR" sz="2400" b="1" dirty="0" err="1">
                 <a:solidFill>
-                  <a:srgbClr val="FF0000"/>
-                </a:solidFill>
-                <a:latin typeface="Times New Roman" panose="02020603050405020304" pitchFamily="18" charset="0"/>
-                <a:cs typeface="Times New Roman" panose="02020603050405020304" pitchFamily="18" charset="0"/>
-              </a:rPr>
-              <a:t>f</a:t>
-            </a:r>
-            <a:r>
-              <a:rPr lang="pt-BR" sz="2400" dirty="0" err="1">
-                <a:solidFill>
-                  <a:schemeClr val="tx1"/>
-                </a:solidFill>
+                  <a:schemeClr val="tx1"/>
+                </a:solidFill>
+                <a:latin typeface="Times New Roman" panose="02020603050405020304" pitchFamily="18" charset="0"/>
+                <a:cs typeface="Times New Roman" panose="02020603050405020304" pitchFamily="18" charset="0"/>
+              </a:rPr>
+              <a:t>insert</a:t>
+            </a:r>
+            <a:r>
+              <a:rPr lang="pt-BR" sz="2400" dirty="0">
+                <a:solidFill>
+                  <a:schemeClr val="tx1"/>
+                </a:solidFill>
+                <a:latin typeface="Times New Roman" panose="02020603050405020304" pitchFamily="18" charset="0"/>
+                <a:cs typeface="Times New Roman" panose="02020603050405020304" pitchFamily="18" charset="0"/>
+              </a:rPr>
+              <a:t> </a:t>
+            </a:r>
+            <a:r>
+              <a:rPr lang="pt-BR" sz="2400" b="1" dirty="0" err="1">
+                <a:solidFill>
+                  <a:schemeClr val="tx1"/>
+                </a:solidFill>
+                <a:latin typeface="Times New Roman" panose="02020603050405020304" pitchFamily="18" charset="0"/>
+                <a:cs typeface="Times New Roman" panose="02020603050405020304" pitchFamily="18" charset="0"/>
+              </a:rPr>
+              <a:t>into</a:t>
+            </a:r>
+            <a:r>
+              <a:rPr lang="pt-BR" sz="2400" dirty="0">
+                <a:solidFill>
+                  <a:schemeClr val="tx1"/>
+                </a:solidFill>
+                <a:latin typeface="Times New Roman" panose="02020603050405020304" pitchFamily="18" charset="0"/>
+                <a:cs typeface="Times New Roman" panose="02020603050405020304" pitchFamily="18" charset="0"/>
+              </a:rPr>
+              <a:t> departamento (nome) </a:t>
+            </a:r>
+            <a:r>
+              <a:rPr lang="pt-BR" sz="2400" b="1" dirty="0" err="1">
+                <a:solidFill>
+                  <a:schemeClr val="tx1"/>
+                </a:solidFill>
+                <a:latin typeface="Times New Roman" panose="02020603050405020304" pitchFamily="18" charset="0"/>
+                <a:cs typeface="Times New Roman" panose="02020603050405020304" pitchFamily="18" charset="0"/>
+              </a:rPr>
+              <a:t>values</a:t>
+            </a:r>
+            <a:r>
+              <a:rPr lang="pt-BR" sz="2400" dirty="0">
+                <a:solidFill>
+                  <a:schemeClr val="tx1"/>
+                </a:solidFill>
+                <a:latin typeface="Times New Roman" panose="02020603050405020304" pitchFamily="18" charset="0"/>
+                <a:cs typeface="Times New Roman" panose="02020603050405020304" pitchFamily="18" charset="0"/>
+              </a:rPr>
+              <a:t> </a:t>
+            </a:r>
+            <a:r>
+              <a:rPr lang="pt-BR" sz="2400" dirty="0">
+                <a:latin typeface="Times New Roman" panose="02020603050405020304" pitchFamily="18" charset="0"/>
+                <a:cs typeface="Times New Roman" panose="02020603050405020304" pitchFamily="18" charset="0"/>
+              </a:rPr>
+              <a:t>(%</a:t>
+            </a:r>
+            <a:r>
+              <a:rPr lang="pt-BR" sz="2400" dirty="0">
+                <a:solidFill>
+                  <a:schemeClr val="tx1"/>
+                </a:solidFill>
+                <a:latin typeface="Times New Roman" panose="02020603050405020304" pitchFamily="18" charset="0"/>
+                <a:cs typeface="Times New Roman" panose="02020603050405020304" pitchFamily="18" charset="0"/>
+              </a:rPr>
+              <a:t>s)</a:t>
+            </a:r>
+            <a:r>
+              <a:rPr lang="pt-BR" sz="2400" dirty="0">
                 <a:latin typeface="Times New Roman" panose="02020603050405020304" pitchFamily="18" charset="0"/>
                 <a:cs typeface="Times New Roman" panose="02020603050405020304" pitchFamily="18" charset="0"/>
               </a:rPr>
               <a:t>"</a:t>
             </a:r>
-            <a:r>
-              <a:rPr lang="pt-BR" sz="2400" b="1" dirty="0" err="1">
-                <a:solidFill>
-                  <a:schemeClr val="tx1"/>
-                </a:solidFill>
-                <a:latin typeface="Times New Roman" panose="02020603050405020304" pitchFamily="18" charset="0"/>
-                <a:cs typeface="Times New Roman" panose="02020603050405020304" pitchFamily="18" charset="0"/>
-              </a:rPr>
-              <a:t>insert</a:t>
-            </a:r>
-            <a:r>
-              <a:rPr lang="pt-BR" sz="2400" dirty="0">
-                <a:solidFill>
-                  <a:schemeClr val="tx1"/>
-                </a:solidFill>
-                <a:latin typeface="Times New Roman" panose="02020603050405020304" pitchFamily="18" charset="0"/>
-                <a:cs typeface="Times New Roman" panose="02020603050405020304" pitchFamily="18" charset="0"/>
-              </a:rPr>
-              <a:t> </a:t>
-            </a:r>
-            <a:r>
-              <a:rPr lang="pt-BR" sz="2400" b="1" dirty="0" err="1">
-                <a:solidFill>
-                  <a:schemeClr val="tx1"/>
-                </a:solidFill>
-                <a:latin typeface="Times New Roman" panose="02020603050405020304" pitchFamily="18" charset="0"/>
-                <a:cs typeface="Times New Roman" panose="02020603050405020304" pitchFamily="18" charset="0"/>
-              </a:rPr>
-              <a:t>into</a:t>
-            </a:r>
-            <a:r>
-              <a:rPr lang="pt-BR" sz="2400" dirty="0">
-                <a:solidFill>
-                  <a:schemeClr val="tx1"/>
-                </a:solidFill>
-                <a:latin typeface="Times New Roman" panose="02020603050405020304" pitchFamily="18" charset="0"/>
-                <a:cs typeface="Times New Roman" panose="02020603050405020304" pitchFamily="18" charset="0"/>
-              </a:rPr>
-              <a:t> departamento (nome) </a:t>
-            </a:r>
-            <a:r>
-              <a:rPr lang="pt-BR" sz="2400" b="1" dirty="0" err="1">
-                <a:solidFill>
-                  <a:schemeClr val="tx1"/>
-                </a:solidFill>
-                <a:latin typeface="Times New Roman" panose="02020603050405020304" pitchFamily="18" charset="0"/>
-                <a:cs typeface="Times New Roman" panose="02020603050405020304" pitchFamily="18" charset="0"/>
-              </a:rPr>
-              <a:t>values</a:t>
-            </a:r>
-            <a:r>
-              <a:rPr lang="pt-BR" sz="2400" dirty="0">
-                <a:solidFill>
-                  <a:schemeClr val="tx1"/>
-                </a:solidFill>
-                <a:latin typeface="Times New Roman" panose="02020603050405020304" pitchFamily="18" charset="0"/>
-                <a:cs typeface="Times New Roman" panose="02020603050405020304" pitchFamily="18" charset="0"/>
-              </a:rPr>
-              <a:t> (</a:t>
-            </a:r>
-            <a:r>
-              <a:rPr lang="pt-BR" sz="2400" b="1" dirty="0">
-                <a:solidFill>
-                  <a:schemeClr val="tx1"/>
-                </a:solidFill>
-                <a:latin typeface="Times New Roman" panose="02020603050405020304" pitchFamily="18" charset="0"/>
-                <a:cs typeface="Times New Roman" panose="02020603050405020304" pitchFamily="18" charset="0"/>
-              </a:rPr>
-              <a:t>‘</a:t>
-            </a:r>
-            <a:r>
-              <a:rPr lang="pt-BR" sz="2400" dirty="0">
-                <a:solidFill>
-                  <a:schemeClr val="tx1"/>
-                </a:solidFill>
-                <a:latin typeface="Times New Roman" panose="02020603050405020304" pitchFamily="18" charset="0"/>
-                <a:cs typeface="Times New Roman" panose="02020603050405020304" pitchFamily="18" charset="0"/>
-              </a:rPr>
-              <a:t>{</a:t>
-            </a:r>
-            <a:r>
-              <a:rPr lang="pt-BR" sz="2400" dirty="0">
-                <a:latin typeface="Times New Roman" panose="02020603050405020304" pitchFamily="18" charset="0"/>
-                <a:cs typeface="Times New Roman" panose="02020603050405020304" pitchFamily="18" charset="0"/>
-              </a:rPr>
-              <a:t>nome</a:t>
-            </a:r>
-            <a:r>
-              <a:rPr lang="pt-BR" sz="2400" dirty="0">
-                <a:solidFill>
-                  <a:schemeClr val="tx1"/>
-                </a:solidFill>
-                <a:latin typeface="Times New Roman" panose="02020603050405020304" pitchFamily="18" charset="0"/>
-                <a:cs typeface="Times New Roman" panose="02020603050405020304" pitchFamily="18" charset="0"/>
-              </a:rPr>
-              <a:t>}’)"</a:t>
-            </a:r>
-          </a:p>
-          <a:p>
-            <a:pPr marL="0" indent="0" algn="just">
-              <a:buNone/>
-            </a:pPr>
             <a:endParaRPr lang="pt-BR" sz="2400" dirty="0">
               <a:solidFill>
                 <a:schemeClr val="tx1"/>
@@ -10683,83 +10755,11 @@
               <a:buNone/>
             </a:pPr>
             <a:r>
-              <a:rPr lang="pt-BR" sz="2400" dirty="0" err="1">
-                <a:solidFill>
-                  <a:schemeClr val="tx1"/>
-                </a:solidFill>
-                <a:latin typeface="Times New Roman" panose="02020603050405020304" pitchFamily="18" charset="0"/>
-                <a:cs typeface="Times New Roman" panose="02020603050405020304" pitchFamily="18" charset="0"/>
-              </a:rPr>
-              <a:t>cursor.</a:t>
-            </a:r>
-            <a:r>
-              <a:rPr lang="pt-BR" sz="2400" b="1" dirty="0" err="1">
-                <a:solidFill>
-                  <a:schemeClr val="tx1"/>
-                </a:solidFill>
-                <a:latin typeface="Times New Roman" panose="02020603050405020304" pitchFamily="18" charset="0"/>
-                <a:cs typeface="Times New Roman" panose="02020603050405020304" pitchFamily="18" charset="0"/>
-              </a:rPr>
-              <a:t>execute</a:t>
-            </a:r>
-            <a:r>
               <a:rPr lang="pt-BR" sz="2400" dirty="0">
-                <a:solidFill>
-                  <a:schemeClr val="tx1"/>
-                </a:solidFill>
-                <a:latin typeface="Times New Roman" panose="02020603050405020304" pitchFamily="18" charset="0"/>
-                <a:cs typeface="Times New Roman" panose="02020603050405020304" pitchFamily="18" charset="0"/>
-              </a:rPr>
-              <a:t>(</a:t>
-            </a:r>
-            <a:r>
-              <a:rPr lang="pt-BR" sz="2400" dirty="0" err="1">
-                <a:solidFill>
-                  <a:schemeClr val="tx1"/>
-                </a:solidFill>
-                <a:latin typeface="Times New Roman" panose="02020603050405020304" pitchFamily="18" charset="0"/>
-                <a:cs typeface="Times New Roman" panose="02020603050405020304" pitchFamily="18" charset="0"/>
-              </a:rPr>
-              <a:t>sql</a:t>
-            </a:r>
-            <a:r>
-              <a:rPr lang="pt-BR" sz="2400" dirty="0">
-                <a:solidFill>
-                  <a:schemeClr val="tx1"/>
-                </a:solidFill>
-                <a:latin typeface="Times New Roman" panose="02020603050405020304" pitchFamily="18" charset="0"/>
-                <a:cs typeface="Times New Roman" panose="02020603050405020304" pitchFamily="18" charset="0"/>
-              </a:rPr>
-              <a:t>)</a:t>
-            </a:r>
-          </a:p>
-          <a:p>
-            <a:pPr marL="0" indent="0" algn="just">
-              <a:buNone/>
-            </a:pPr>
-            <a:r>
-              <a:rPr lang="pt-BR" sz="2400" dirty="0" err="1">
-                <a:latin typeface="Times New Roman" panose="02020603050405020304" pitchFamily="18" charset="0"/>
-                <a:cs typeface="Times New Roman" panose="02020603050405020304" pitchFamily="18" charset="0"/>
-              </a:rPr>
-              <a:t>conn.</a:t>
-            </a:r>
-            <a:r>
-              <a:rPr lang="pt-BR" sz="2400" b="1" dirty="0" err="1">
-                <a:solidFill>
-                  <a:srgbClr val="FF0000"/>
-                </a:solidFill>
-                <a:latin typeface="Times New Roman" panose="02020603050405020304" pitchFamily="18" charset="0"/>
-                <a:cs typeface="Times New Roman" panose="02020603050405020304" pitchFamily="18" charset="0"/>
-              </a:rPr>
-              <a:t>commit</a:t>
-            </a:r>
-            <a:r>
-              <a:rPr lang="pt-BR" sz="2400" dirty="0">
-                <a:latin typeface="Times New Roman" panose="02020603050405020304" pitchFamily="18" charset="0"/>
-                <a:cs typeface="Times New Roman" panose="02020603050405020304" pitchFamily="18" charset="0"/>
-              </a:rPr>
-              <a:t>();</a:t>
+                <a:latin typeface="Times New Roman" panose="02020603050405020304" pitchFamily="18" charset="0"/>
+                <a:cs typeface="Times New Roman" panose="02020603050405020304" pitchFamily="18" charset="0"/>
+              </a:rPr>
+              <a:t>valor = (nome,)</a:t>
             </a:r>
             <a:endParaRPr lang="pt-BR" sz="2400" dirty="0">
               <a:solidFill>
@@ -10774,6 +10774,97 @@
               <a:buNone/>
             </a:pPr>
             <a:r>
+              <a:rPr lang="pt-BR" sz="2400" dirty="0" err="1">
+                <a:solidFill>
+                  <a:schemeClr val="tx1"/>
+                </a:solidFill>
+                <a:latin typeface="Times New Roman" panose="02020603050405020304" pitchFamily="18" charset="0"/>
+                <a:cs typeface="Times New Roman" panose="02020603050405020304" pitchFamily="18" charset="0"/>
+              </a:rPr>
+              <a:t>cursor.</a:t>
+            </a:r>
+            <a:r>
+              <a:rPr lang="pt-BR" sz="2400" b="1" dirty="0" err="1">
+                <a:solidFill>
+                  <a:schemeClr val="tx1"/>
+                </a:solidFill>
+                <a:latin typeface="Times New Roman" panose="02020603050405020304" pitchFamily="18" charset="0"/>
+                <a:cs typeface="Times New Roman" panose="02020603050405020304" pitchFamily="18" charset="0"/>
+              </a:rPr>
+              <a:t>execute</a:t>
+            </a:r>
+            <a:r>
+              <a:rPr lang="pt-BR" sz="2400" dirty="0">
+                <a:solidFill>
+                  <a:schemeClr val="tx1"/>
+                </a:solidFill>
+                <a:latin typeface="Times New Roman" panose="02020603050405020304" pitchFamily="18" charset="0"/>
+                <a:cs typeface="Times New Roman" panose="02020603050405020304" pitchFamily="18" charset="0"/>
+              </a:rPr>
+              <a:t>(</a:t>
+            </a:r>
+            <a:r>
+              <a:rPr lang="pt-BR" sz="2400" dirty="0" err="1">
+                <a:solidFill>
+                  <a:schemeClr val="tx1"/>
+                </a:solidFill>
+                <a:latin typeface="Times New Roman" panose="02020603050405020304" pitchFamily="18" charset="0"/>
+                <a:cs typeface="Times New Roman" panose="02020603050405020304" pitchFamily="18" charset="0"/>
+              </a:rPr>
+              <a:t>sql</a:t>
+            </a:r>
+            <a:r>
+              <a:rPr lang="pt-BR" sz="2400" dirty="0">
+                <a:solidFill>
+                  <a:schemeClr val="tx1"/>
+                </a:solidFill>
+                <a:latin typeface="Times New Roman" panose="02020603050405020304" pitchFamily="18" charset="0"/>
+                <a:cs typeface="Times New Roman" panose="02020603050405020304" pitchFamily="18" charset="0"/>
+              </a:rPr>
+              <a:t>, valor)</a:t>
+            </a:r>
+          </a:p>
+          <a:p>
+            <a:pPr marL="0" indent="0" algn="just">
+              <a:buNone/>
+            </a:pPr>
+            <a:r>
+              <a:rPr lang="pt-BR" sz="2400" dirty="0" err="1">
+                <a:latin typeface="Times New Roman" panose="02020603050405020304" pitchFamily="18" charset="0"/>
+                <a:cs typeface="Times New Roman" panose="02020603050405020304" pitchFamily="18" charset="0"/>
+              </a:rPr>
+              <a:t>conn.</a:t>
+            </a:r>
+            <a:r>
+              <a:rPr lang="pt-BR" sz="2400" b="1" dirty="0" err="1">
+                <a:solidFill>
+                  <a:srgbClr val="FF0000"/>
+                </a:solidFill>
+                <a:latin typeface="Times New Roman" panose="02020603050405020304" pitchFamily="18" charset="0"/>
+                <a:cs typeface="Times New Roman" panose="02020603050405020304" pitchFamily="18" charset="0"/>
+              </a:rPr>
+              <a:t>commit</a:t>
+            </a:r>
+            <a:r>
+              <a:rPr lang="pt-BR" sz="2400" dirty="0">
+                <a:latin typeface="Times New Roman" panose="02020603050405020304" pitchFamily="18" charset="0"/>
+                <a:cs typeface="Times New Roman" panose="02020603050405020304" pitchFamily="18" charset="0"/>
+              </a:rPr>
+              <a:t>()</a:t>
+            </a:r>
+            <a:endParaRPr lang="pt-BR" sz="2400" dirty="0">
+              <a:solidFill>
+                <a:schemeClr val="tx1"/>
+              </a:solidFill>
+              <a:latin typeface="Times New Roman" panose="02020603050405020304" pitchFamily="18" charset="0"/>
+              <a:cs typeface="Times New Roman" panose="02020603050405020304" pitchFamily="18" charset="0"/>
+            </a:endParaRPr>
+          </a:p>
+          <a:p>
+            <a:pPr marL="0" indent="0" algn="just">
+              <a:buNone/>
+            </a:pPr>
+            <a:r>
               <a:rPr lang="pt-BR" sz="2400" b="1" dirty="0">
                 <a:latin typeface="Times New Roman" panose="02020603050405020304" pitchFamily="18" charset="0"/>
                 <a:cs typeface="Times New Roman" panose="02020603050405020304" pitchFamily="18" charset="0"/>
@@ -10785,7 +10876,7 @@
                 <a:latin typeface="Times New Roman" panose="02020603050405020304" pitchFamily="18" charset="0"/>
                 <a:cs typeface="Times New Roman" panose="02020603050405020304" pitchFamily="18" charset="0"/>
               </a:rPr>
-              <a:t>(“Inserido com sucesso”</a:t>
+              <a:t>("Inserido com sucesso"</a:t>
             </a:r>
             <a:endParaRPr lang="pt-BR" sz="2400" dirty="0">
               <a:solidFill>

</xml_diff>